<commit_message>
fix: remove Q&A slide to strictly match Markdown report
</commit_message>
<xml_diff>
--- a/docs/presentations/Crypto-Agility_Navigator_Review2.pptx
+++ b/docs/presentations/Crypto-Agility_Navigator_Review2.pptx
@@ -42,10 +42,9 @@
     <p:sldId id="290" r:id="rId36"/>
     <p:sldId id="291" r:id="rId37"/>
     <p:sldId id="292" r:id="rId38"/>
-    <p:sldId id="293" r:id="rId39"/>
   </p:sldIdLst>
   <p:notesMasterIdLst>
-    <p:notesMasterId r:id="rId40"/>
+    <p:notesMasterId r:id="rId39"/>
   </p:notesMasterIdLst>
   <p:sldSz cx="9144000" cy="5143500"/>
   <p:notesSz cx="5143500" cy="9144000"/>
@@ -3203,94 +3202,6 @@
             <a:fld id="{F7021451-1387-4CA6-816F-3879F97B5CBC}" type="slidenum">
               <a:rPr lang="en-US"/>
               <a:t>37</a:t>
-            </a:fld>
-            <a:endParaRPr lang="en-US"/>
-          </a:p>
-        </p:txBody>
-      </p:sp>
-    </p:spTree>
-    <p:extLst>
-      <p:ext uri="{BB962C8B-B14F-4D97-AF65-F5344CB8AC3E}">
-        <p14:creationId xmlns:p14="http://schemas.microsoft.com/office/powerpoint/2010/main" val="1024086991"/>
-      </p:ext>
-    </p:extLst>
-  </p:cSld>
-  <p:clrMapOvr>
-    <a:masterClrMapping/>
-  </p:clrMapOvr>
-</p:notes>
-</file>
-
-<file path=ppt/notesSlides/notesSlide38.xml><?xml version="1.0" encoding="utf-8"?>
-<p:notes xmlns:a="http://schemas.openxmlformats.org/drawingml/2006/main" xmlns:r="http://schemas.openxmlformats.org/officeDocument/2006/relationships" xmlns:p="http://schemas.openxmlformats.org/presentationml/2006/main">
-  <p:cSld>
-    <p:spTree>
-      <p:nvGrpSpPr>
-        <p:cNvPr id="1" name=""/>
-        <p:cNvGrpSpPr/>
-        <p:nvPr/>
-      </p:nvGrpSpPr>
-      <p:grpSpPr>
-        <a:xfrm>
-          <a:off x="0" y="0"/>
-          <a:ext cx="0" cy="0"/>
-          <a:chOff x="0" y="0"/>
-          <a:chExt cx="0" cy="0"/>
-        </a:xfrm>
-      </p:grpSpPr>
-      <p:sp>
-        <p:nvSpPr>
-          <p:cNvPr id="2" name="Slide Image Placeholder 1"/>
-          <p:cNvSpPr>
-            <a:spLocks noGrp="1" noRot="1" noChangeAspect="1"/>
-          </p:cNvSpPr>
-          <p:nvPr>
-            <p:ph type="sldImg"/>
-          </p:nvPr>
-        </p:nvSpPr>
-        <p:spPr/>
-      </p:sp>
-      <p:sp>
-        <p:nvSpPr>
-          <p:cNvPr id="3" name="Notes Placeholder 2"/>
-          <p:cNvSpPr>
-            <a:spLocks noGrp="1"/>
-          </p:cNvSpPr>
-          <p:nvPr>
-            <p:ph type="body" idx="1"/>
-          </p:nvPr>
-        </p:nvSpPr>
-        <p:spPr/>
-        <p:txBody>
-          <a:bodyPr/>
-          <a:lstStyle/>
-          <a:p>
-            <a:r>
-              <a:rPr lang="en-US" dirty="0"/>
-              <a:t/>
-            </a:r>
-            <a:endParaRPr lang="en-US" dirty="0"/>
-          </a:p>
-        </p:txBody>
-      </p:sp>
-      <p:sp>
-        <p:nvSpPr>
-          <p:cNvPr id="4" name="Slide Number Placeholder 3"/>
-          <p:cNvSpPr>
-            <a:spLocks noGrp="1"/>
-          </p:cNvSpPr>
-          <p:nvPr>
-            <p:ph type="sldNum" sz="quarter" idx="10"/>
-          </p:nvPr>
-        </p:nvSpPr>
-        <p:spPr/>
-        <p:txBody>
-          <a:bodyPr/>
-          <a:lstStyle/>
-          <a:p>
-            <a:fld id="{F7021451-1387-4CA6-816F-3879F97B5CBC}" type="slidenum">
-              <a:rPr lang="en-US"/>
-              <a:t>38</a:t>
             </a:fld>
             <a:endParaRPr lang="en-US"/>
           </a:p>
@@ -4507,7 +4418,7 @@
                 <a:ea typeface="Arial" pitchFamily="34" charset="-122"/>
                 <a:cs typeface="Arial" pitchFamily="34" charset="-120"/>
               </a:rPr>
-              <a:t>01 / 37</a:t>
+              <a:t>01 / 36</a:t>
             </a:r>
             <a:endParaRPr lang="en-US" sz="850" dirty="0"/>
           </a:p>
@@ -4819,7 +4730,7 @@
                 <a:ea typeface="Arial" pitchFamily="34" charset="-122"/>
                 <a:cs typeface="Arial" pitchFamily="34" charset="-120"/>
               </a:rPr>
-              <a:t>10 / 37</a:t>
+              <a:t>10 / 36</a:t>
             </a:r>
             <a:endParaRPr lang="en-US" sz="850" dirty="0"/>
           </a:p>
@@ -5856,7 +5767,7 @@
                 <a:ea typeface="Arial" pitchFamily="34" charset="-122"/>
                 <a:cs typeface="Arial" pitchFamily="34" charset="-120"/>
               </a:rPr>
-              <a:t>11 / 37</a:t>
+              <a:t>11 / 36</a:t>
             </a:r>
             <a:endParaRPr lang="en-US" sz="850" dirty="0"/>
           </a:p>
@@ -6846,7 +6757,7 @@
                 <a:ea typeface="Arial" pitchFamily="34" charset="-122"/>
                 <a:cs typeface="Arial" pitchFamily="34" charset="-120"/>
               </a:rPr>
-              <a:t>12 / 37</a:t>
+              <a:t>12 / 36</a:t>
             </a:r>
             <a:endParaRPr lang="en-US" sz="850" dirty="0"/>
           </a:p>
@@ -7894,7 +7805,7 @@
                 <a:ea typeface="Arial" pitchFamily="34" charset="-122"/>
                 <a:cs typeface="Arial" pitchFamily="34" charset="-120"/>
               </a:rPr>
-              <a:t>13 / 37</a:t>
+              <a:t>13 / 36</a:t>
             </a:r>
             <a:endParaRPr lang="en-US" sz="850" dirty="0"/>
           </a:p>
@@ -8942,7 +8853,7 @@
                 <a:ea typeface="Arial" pitchFamily="34" charset="-122"/>
                 <a:cs typeface="Arial" pitchFamily="34" charset="-120"/>
               </a:rPr>
-              <a:t>14 / 37</a:t>
+              <a:t>14 / 36</a:t>
             </a:r>
             <a:endParaRPr lang="en-US" sz="850" dirty="0"/>
           </a:p>
@@ -9890,7 +9801,7 @@
                 <a:ea typeface="Arial" pitchFamily="34" charset="-122"/>
                 <a:cs typeface="Arial" pitchFamily="34" charset="-120"/>
               </a:rPr>
-              <a:t>15 / 37</a:t>
+              <a:t>15 / 36</a:t>
             </a:r>
             <a:endParaRPr lang="en-US" sz="850" dirty="0"/>
           </a:p>
@@ -11214,7 +11125,7 @@
                 <a:ea typeface="Arial" pitchFamily="34" charset="-122"/>
                 <a:cs typeface="Arial" pitchFamily="34" charset="-120"/>
               </a:rPr>
-              <a:t>16 / 37</a:t>
+              <a:t>16 / 36</a:t>
             </a:r>
             <a:endParaRPr lang="en-US" sz="850" dirty="0"/>
           </a:p>
@@ -11953,7 +11864,7 @@
                 <a:ea typeface="Arial" pitchFamily="34" charset="-122"/>
                 <a:cs typeface="Arial" pitchFamily="34" charset="-120"/>
               </a:rPr>
-              <a:t>17 / 37</a:t>
+              <a:t>17 / 36</a:t>
             </a:r>
             <a:endParaRPr lang="en-US" sz="850" dirty="0"/>
           </a:p>
@@ -12753,7 +12664,7 @@
                 <a:ea typeface="Arial" pitchFamily="34" charset="-122"/>
                 <a:cs typeface="Arial" pitchFamily="34" charset="-120"/>
               </a:rPr>
-              <a:t>18 / 37</a:t>
+              <a:t>18 / 36</a:t>
             </a:r>
             <a:endParaRPr lang="en-US" sz="850" dirty="0"/>
           </a:p>
@@ -13957,7 +13868,7 @@
                 <a:ea typeface="Arial" pitchFamily="34" charset="-122"/>
                 <a:cs typeface="Arial" pitchFamily="34" charset="-120"/>
               </a:rPr>
-              <a:t>19 / 37</a:t>
+              <a:t>19 / 36</a:t>
             </a:r>
             <a:endParaRPr lang="en-US" sz="850" dirty="0"/>
           </a:p>
@@ -14747,7 +14658,7 @@
                 <a:ea typeface="Arial" pitchFamily="34" charset="-122"/>
                 <a:cs typeface="Arial" pitchFamily="34" charset="-120"/>
               </a:rPr>
-              <a:t>02 / 37</a:t>
+              <a:t>02 / 36</a:t>
             </a:r>
             <a:endParaRPr lang="en-US" sz="850" dirty="0"/>
           </a:p>
@@ -15660,7 +15571,7 @@
                 <a:ea typeface="Arial" pitchFamily="34" charset="-122"/>
                 <a:cs typeface="Arial" pitchFamily="34" charset="-120"/>
               </a:rPr>
-              <a:t>20 / 37</a:t>
+              <a:t>20 / 36</a:t>
             </a:r>
             <a:endParaRPr lang="en-US" sz="850" dirty="0"/>
           </a:p>
@@ -16428,7 +16339,7 @@
                 <a:ea typeface="Arial" pitchFamily="34" charset="-122"/>
                 <a:cs typeface="Arial" pitchFamily="34" charset="-120"/>
               </a:rPr>
-              <a:t>21 / 37</a:t>
+              <a:t>21 / 36</a:t>
             </a:r>
             <a:endParaRPr lang="en-US" sz="850" dirty="0"/>
           </a:p>
@@ -16951,7 +16862,7 @@
                 <a:ea typeface="Arial" pitchFamily="34" charset="-122"/>
                 <a:cs typeface="Arial" pitchFamily="34" charset="-120"/>
               </a:rPr>
-              <a:t>22 / 37</a:t>
+              <a:t>22 / 36</a:t>
             </a:r>
             <a:endParaRPr lang="en-US" sz="850" dirty="0"/>
           </a:p>
@@ -17474,7 +17385,7 @@
                 <a:ea typeface="Arial" pitchFamily="34" charset="-122"/>
                 <a:cs typeface="Arial" pitchFamily="34" charset="-120"/>
               </a:rPr>
-              <a:t>23 / 37</a:t>
+              <a:t>23 / 36</a:t>
             </a:r>
             <a:endParaRPr lang="en-US" sz="850" dirty="0"/>
           </a:p>
@@ -18015,7 +17926,7 @@
                 <a:ea typeface="Arial" pitchFamily="34" charset="-122"/>
                 <a:cs typeface="Arial" pitchFamily="34" charset="-120"/>
               </a:rPr>
-              <a:t>24 / 37</a:t>
+              <a:t>24 / 36</a:t>
             </a:r>
             <a:endParaRPr lang="en-US" sz="850" dirty="0"/>
           </a:p>
@@ -18719,7 +18630,7 @@
                 <a:ea typeface="Arial" pitchFamily="34" charset="-122"/>
                 <a:cs typeface="Arial" pitchFamily="34" charset="-120"/>
               </a:rPr>
-              <a:t>25 / 37</a:t>
+              <a:t>25 / 36</a:t>
             </a:r>
             <a:endParaRPr lang="en-US" sz="850" dirty="0"/>
           </a:p>
@@ -19423,7 +19334,7 @@
                 <a:ea typeface="Arial" pitchFamily="34" charset="-122"/>
                 <a:cs typeface="Arial" pitchFamily="34" charset="-120"/>
               </a:rPr>
-              <a:t>26 / 37</a:t>
+              <a:t>26 / 36</a:t>
             </a:r>
             <a:endParaRPr lang="en-US" sz="850" dirty="0"/>
           </a:p>
@@ -20198,7 +20109,7 @@
                 <a:ea typeface="Arial" pitchFamily="34" charset="-122"/>
                 <a:cs typeface="Arial" pitchFamily="34" charset="-120"/>
               </a:rPr>
-              <a:t>27 / 37</a:t>
+              <a:t>27 / 36</a:t>
             </a:r>
             <a:endParaRPr lang="en-US" sz="850" dirty="0"/>
           </a:p>
@@ -20721,7 +20632,7 @@
                 <a:ea typeface="Arial" pitchFamily="34" charset="-122"/>
                 <a:cs typeface="Arial" pitchFamily="34" charset="-120"/>
               </a:rPr>
-              <a:t>28 / 37</a:t>
+              <a:t>28 / 36</a:t>
             </a:r>
             <a:endParaRPr lang="en-US" sz="850" dirty="0"/>
           </a:p>
@@ -21407,7 +21318,7 @@
                 <a:ea typeface="Arial" pitchFamily="34" charset="-122"/>
                 <a:cs typeface="Arial" pitchFamily="34" charset="-120"/>
               </a:rPr>
-              <a:t>29 / 37</a:t>
+              <a:t>29 / 36</a:t>
             </a:r>
             <a:endParaRPr lang="en-US" sz="850" dirty="0"/>
           </a:p>
@@ -21959,7 +21870,7 @@
                 <a:ea typeface="Arial" pitchFamily="34" charset="-122"/>
                 <a:cs typeface="Arial" pitchFamily="34" charset="-120"/>
               </a:rPr>
-              <a:t>03 / 37</a:t>
+              <a:t>03 / 36</a:t>
             </a:r>
             <a:endParaRPr lang="en-US" sz="850" dirty="0"/>
           </a:p>
@@ -22509,7 +22420,7 @@
                 <a:ea typeface="Arial" pitchFamily="34" charset="-122"/>
                 <a:cs typeface="Arial" pitchFamily="34" charset="-120"/>
               </a:rPr>
-              <a:t>30 / 37</a:t>
+              <a:t>30 / 36</a:t>
             </a:r>
             <a:endParaRPr lang="en-US" sz="850" dirty="0"/>
           </a:p>
@@ -23050,7 +22961,7 @@
                 <a:ea typeface="Arial" pitchFamily="34" charset="-122"/>
                 <a:cs typeface="Arial" pitchFamily="34" charset="-120"/>
               </a:rPr>
-              <a:t>31 / 37</a:t>
+              <a:t>31 / 36</a:t>
             </a:r>
             <a:endParaRPr lang="en-US" sz="850" dirty="0"/>
           </a:p>
@@ -23601,7 +23512,7 @@
                 <a:ea typeface="Arial" pitchFamily="34" charset="-122"/>
                 <a:cs typeface="Arial" pitchFamily="34" charset="-120"/>
               </a:rPr>
-              <a:t>32 / 37</a:t>
+              <a:t>32 / 36</a:t>
             </a:r>
             <a:endParaRPr lang="en-US" sz="850" dirty="0"/>
           </a:p>
@@ -24323,7 +24234,7 @@
                 <a:ea typeface="Arial" pitchFamily="34" charset="-122"/>
                 <a:cs typeface="Arial" pitchFamily="34" charset="-120"/>
               </a:rPr>
-              <a:t>33 / 37</a:t>
+              <a:t>33 / 36</a:t>
             </a:r>
             <a:endParaRPr lang="en-US" sz="850" dirty="0"/>
           </a:p>
@@ -24810,7 +24721,7 @@
                 <a:ea typeface="Arial" pitchFamily="34" charset="-122"/>
                 <a:cs typeface="Arial" pitchFamily="34" charset="-120"/>
               </a:rPr>
-              <a:t>34 / 37</a:t>
+              <a:t>34 / 36</a:t>
             </a:r>
             <a:endParaRPr lang="en-US" sz="850" dirty="0"/>
           </a:p>
@@ -26460,7 +26371,7 @@
                 <a:ea typeface="Arial" pitchFamily="34" charset="-122"/>
                 <a:cs typeface="Arial" pitchFamily="34" charset="-120"/>
               </a:rPr>
-              <a:t>35 / 37</a:t>
+              <a:t>35 / 36</a:t>
             </a:r>
             <a:endParaRPr lang="en-US" sz="850" dirty="0"/>
           </a:p>
@@ -27282,7 +27193,7 @@
                 <a:ea typeface="Arial" pitchFamily="34" charset="-122"/>
                 <a:cs typeface="Arial" pitchFamily="34" charset="-120"/>
               </a:rPr>
-              <a:t>36 / 37</a:t>
+              <a:t>36 / 36</a:t>
             </a:r>
             <a:endParaRPr lang="en-US" sz="850" dirty="0"/>
           </a:p>
@@ -28498,7 +28409,7 @@
                 <a:ea typeface="Arial" pitchFamily="34" charset="-122"/>
                 <a:cs typeface="Arial" pitchFamily="34" charset="-120"/>
               </a:rPr>
-              <a:t>37 / 37</a:t>
+              <a:t>37 / 36</a:t>
             </a:r>
             <a:endParaRPr lang="en-US" sz="850" dirty="0"/>
           </a:p>
@@ -28766,636 +28677,6 @@
               <a:t>  - Built full-stack REST API server (server.py) and 100% passing unit test suite (tests/test_navigator.py).</a:t>
             </a:r>
             <a:endParaRPr lang="en-US" sz="800" dirty="0"/>
-          </a:p>
-        </p:txBody>
-      </p:sp>
-    </p:spTree>
-  </p:cSld>
-  <p:clrMapOvr>
-    <a:masterClrMapping/>
-  </p:clrMapOvr>
-</p:sld>
-</file>
-
-<file path=ppt/slides/slide38.xml><?xml version="1.0" encoding="utf-8"?>
-<p:sld xmlns:a="http://schemas.openxmlformats.org/drawingml/2006/main" xmlns:r="http://schemas.openxmlformats.org/officeDocument/2006/relationships" xmlns:p="http://schemas.openxmlformats.org/presentationml/2006/main">
-  <p:cSld name="Slide 38">
-    <p:bg>
-      <p:bgPr>
-        <a:solidFill>
-          <a:srgbClr val="FFFFFF"/>
-        </a:solidFill>
-      </p:bgPr>
-    </p:bg>
-    <p:spTree>
-      <p:nvGrpSpPr>
-        <p:cNvPr id="1" name=""/>
-        <p:cNvGrpSpPr/>
-        <p:nvPr/>
-      </p:nvGrpSpPr>
-      <p:grpSpPr>
-        <a:xfrm>
-          <a:off x="0" y="0"/>
-          <a:ext cx="0" cy="0"/>
-          <a:chOff x="0" y="0"/>
-          <a:chExt cx="0" cy="0"/>
-        </a:xfrm>
-      </p:grpSpPr>
-      <p:sp>
-        <p:nvSpPr>
-          <p:cNvPr id="2" name="Shape 0"/>
-          <p:cNvSpPr/>
-          <p:nvPr/>
-        </p:nvSpPr>
-        <p:spPr>
-          <a:xfrm>
-            <a:off x="457200" y="621792"/>
-            <a:ext cx="8229600" cy="0"/>
-          </a:xfrm>
-          <a:prstGeom prst="line">
-            <a:avLst/>
-          </a:prstGeom>
-          <a:noFill/>
-          <a:ln w="12700">
-            <a:solidFill>
-              <a:srgbClr val="E0E0E0"/>
-            </a:solidFill>
-            <a:prstDash val="solid"/>
-          </a:ln>
-        </p:spPr>
-      </p:sp>
-      <p:sp>
-        <p:nvSpPr>
-          <p:cNvPr id="3" name="Text 1"/>
-          <p:cNvSpPr/>
-          <p:nvPr/>
-        </p:nvSpPr>
-        <p:spPr>
-          <a:xfrm>
-            <a:off x="457200" y="320040"/>
-            <a:ext cx="5029200" cy="228600"/>
-          </a:xfrm>
-          <a:prstGeom prst="rect">
-            <a:avLst/>
-          </a:prstGeom>
-          <a:noFill/>
-          <a:ln/>
-        </p:spPr>
-        <p:txBody>
-          <a:bodyPr wrap="square" rtlCol="0" anchor="ctr"/>
-          <a:lstStyle/>
-          <a:p>
-            <a:pPr indent="0" marL="0">
-              <a:buNone/>
-            </a:pPr>
-            <a:r>
-              <a:rPr lang="en-US" sz="900" b="1" dirty="0">
-                <a:solidFill>
-                  <a:srgbClr val="666666"/>
-                </a:solidFill>
-                <a:latin typeface="Arial" pitchFamily="34" charset="0"/>
-                <a:ea typeface="Arial" pitchFamily="34" charset="-122"/>
-                <a:cs typeface="Arial" pitchFamily="34" charset="-120"/>
-              </a:rPr>
-              <a:t>CRYPTO-AGILITY NAVIGATOR</a:t>
-            </a:r>
-            <a:endParaRPr lang="en-US" sz="900" dirty="0"/>
-          </a:p>
-        </p:txBody>
-      </p:sp>
-      <p:sp>
-        <p:nvSpPr>
-          <p:cNvPr id="4" name="Text 2"/>
-          <p:cNvSpPr/>
-          <p:nvPr/>
-        </p:nvSpPr>
-        <p:spPr>
-          <a:xfrm>
-            <a:off x="4572000" y="320040"/>
-            <a:ext cx="4114800" cy="228600"/>
-          </a:xfrm>
-          <a:prstGeom prst="rect">
-            <a:avLst/>
-          </a:prstGeom>
-          <a:noFill/>
-          <a:ln/>
-        </p:spPr>
-        <p:txBody>
-          <a:bodyPr wrap="square" rtlCol="0" anchor="ctr"/>
-          <a:lstStyle/>
-          <a:p>
-            <a:pPr algn="r" indent="0" marL="0">
-              <a:buNone/>
-            </a:pPr>
-            <a:r>
-              <a:rPr lang="en-US" sz="900" b="1" dirty="0">
-                <a:solidFill>
-                  <a:srgbClr val="666666"/>
-                </a:solidFill>
-                <a:latin typeface="Arial" pitchFamily="34" charset="0"/>
-                <a:ea typeface="Arial" pitchFamily="34" charset="-122"/>
-                <a:cs typeface="Arial" pitchFamily="34" charset="-120"/>
-              </a:rPr>
-              <a:t>PARAMETER 7 (2 M)</a:t>
-            </a:r>
-            <a:endParaRPr lang="en-US" sz="900" dirty="0"/>
-          </a:p>
-        </p:txBody>
-      </p:sp>
-      <p:sp>
-        <p:nvSpPr>
-          <p:cNvPr id="5" name="Text 3"/>
-          <p:cNvSpPr/>
-          <p:nvPr/>
-        </p:nvSpPr>
-        <p:spPr>
-          <a:xfrm>
-            <a:off x="457200" y="777240"/>
-            <a:ext cx="8229600" cy="274320"/>
-          </a:xfrm>
-          <a:prstGeom prst="rect">
-            <a:avLst/>
-          </a:prstGeom>
-          <a:noFill/>
-          <a:ln/>
-        </p:spPr>
-        <p:txBody>
-          <a:bodyPr wrap="square" rtlCol="0" anchor="ctr"/>
-          <a:lstStyle/>
-          <a:p>
-            <a:pPr indent="0" marL="0">
-              <a:buNone/>
-            </a:pPr>
-            <a:r>
-              <a:rPr lang="en-US" sz="1200" b="1" dirty="0">
-                <a:solidFill>
-                  <a:srgbClr val="666666"/>
-                </a:solidFill>
-                <a:latin typeface="Arial" pitchFamily="34" charset="0"/>
-                <a:ea typeface="Arial" pitchFamily="34" charset="-122"/>
-                <a:cs typeface="Arial" pitchFamily="34" charset="-120"/>
-              </a:rPr>
-              <a:t>10.2 PANEL DEFENSE &amp; TECHNICAL Q&amp;A</a:t>
-            </a:r>
-            <a:endParaRPr lang="en-US" sz="1200" dirty="0"/>
-          </a:p>
-        </p:txBody>
-      </p:sp>
-      <p:sp>
-        <p:nvSpPr>
-          <p:cNvPr id="6" name="Text 4"/>
-          <p:cNvSpPr/>
-          <p:nvPr/>
-        </p:nvSpPr>
-        <p:spPr>
-          <a:xfrm>
-            <a:off x="457200" y="1051560"/>
-            <a:ext cx="8229600" cy="411480"/>
-          </a:xfrm>
-          <a:prstGeom prst="rect">
-            <a:avLst/>
-          </a:prstGeom>
-          <a:noFill/>
-          <a:ln/>
-        </p:spPr>
-        <p:txBody>
-          <a:bodyPr wrap="square" rtlCol="0" anchor="ctr"/>
-          <a:lstStyle/>
-          <a:p>
-            <a:pPr indent="0" marL="0">
-              <a:buNone/>
-            </a:pPr>
-            <a:r>
-              <a:rPr lang="en-US" sz="1800" b="1" dirty="0">
-                <a:solidFill>
-                  <a:srgbClr val="000000"/>
-                </a:solidFill>
-                <a:latin typeface="Arial" pitchFamily="34" charset="0"/>
-                <a:ea typeface="Arial" pitchFamily="34" charset="-122"/>
-                <a:cs typeface="Arial" pitchFamily="34" charset="-120"/>
-              </a:rPr>
-              <a:t>Anticipating Technical Inquiries from the School Panel</a:t>
-            </a:r>
-            <a:endParaRPr lang="en-US" sz="1800" dirty="0"/>
-          </a:p>
-        </p:txBody>
-      </p:sp>
-      <p:sp>
-        <p:nvSpPr>
-          <p:cNvPr id="7" name="Shape 5"/>
-          <p:cNvSpPr/>
-          <p:nvPr/>
-        </p:nvSpPr>
-        <p:spPr>
-          <a:xfrm>
-            <a:off x="457200" y="4709160"/>
-            <a:ext cx="8229600" cy="0"/>
-          </a:xfrm>
-          <a:prstGeom prst="line">
-            <a:avLst/>
-          </a:prstGeom>
-          <a:noFill/>
-          <a:ln w="12700">
-            <a:solidFill>
-              <a:srgbClr val="E0E0E0"/>
-            </a:solidFill>
-            <a:prstDash val="solid"/>
-          </a:ln>
-        </p:spPr>
-      </p:sp>
-      <p:sp>
-        <p:nvSpPr>
-          <p:cNvPr id="8" name="Text 6"/>
-          <p:cNvSpPr/>
-          <p:nvPr/>
-        </p:nvSpPr>
-        <p:spPr>
-          <a:xfrm>
-            <a:off x="457200" y="4800600"/>
-            <a:ext cx="5943600" cy="228600"/>
-          </a:xfrm>
-          <a:prstGeom prst="rect">
-            <a:avLst/>
-          </a:prstGeom>
-          <a:noFill/>
-          <a:ln/>
-        </p:spPr>
-        <p:txBody>
-          <a:bodyPr wrap="square" rtlCol="0" anchor="ctr"/>
-          <a:lstStyle/>
-          <a:p>
-            <a:pPr indent="0" marL="0">
-              <a:buNone/>
-            </a:pPr>
-            <a:r>
-              <a:rPr lang="en-US" sz="850" b="1" dirty="0">
-                <a:solidFill>
-                  <a:srgbClr val="666666"/>
-                </a:solidFill>
-                <a:latin typeface="Arial" pitchFamily="34" charset="0"/>
-                <a:ea typeface="Arial" pitchFamily="34" charset="-122"/>
-                <a:cs typeface="Arial" pitchFamily="34" charset="-120"/>
-              </a:rPr>
-              <a:t>PARAMETER 7 (2 M)</a:t>
-            </a:r>
-            <a:endParaRPr lang="en-US" sz="850" dirty="0"/>
-          </a:p>
-        </p:txBody>
-      </p:sp>
-      <p:sp>
-        <p:nvSpPr>
-          <p:cNvPr id="9" name="Text 7"/>
-          <p:cNvSpPr/>
-          <p:nvPr/>
-        </p:nvSpPr>
-        <p:spPr>
-          <a:xfrm>
-            <a:off x="6858000" y="4800600"/>
-            <a:ext cx="1828800" cy="228600"/>
-          </a:xfrm>
-          <a:prstGeom prst="rect">
-            <a:avLst/>
-          </a:prstGeom>
-          <a:noFill/>
-          <a:ln/>
-        </p:spPr>
-        <p:txBody>
-          <a:bodyPr wrap="square" rtlCol="0" anchor="ctr"/>
-          <a:lstStyle/>
-          <a:p>
-            <a:pPr algn="r" indent="0" marL="0">
-              <a:buNone/>
-            </a:pPr>
-            <a:r>
-              <a:rPr lang="en-US" sz="850" b="1" dirty="0">
-                <a:solidFill>
-                  <a:srgbClr val="666666"/>
-                </a:solidFill>
-                <a:latin typeface="Arial" pitchFamily="34" charset="0"/>
-                <a:ea typeface="Arial" pitchFamily="34" charset="-122"/>
-                <a:cs typeface="Arial" pitchFamily="34" charset="-120"/>
-              </a:rPr>
-              <a:t>38 / 37</a:t>
-            </a:r>
-            <a:endParaRPr lang="en-US" sz="850" dirty="0"/>
-          </a:p>
-        </p:txBody>
-      </p:sp>
-      <p:sp>
-        <p:nvSpPr>
-          <p:cNvPr id="10" name="Shape 8"/>
-          <p:cNvSpPr/>
-          <p:nvPr/>
-        </p:nvSpPr>
-        <p:spPr>
-          <a:xfrm>
-            <a:off x="457200" y="1645920"/>
-            <a:ext cx="8229600" cy="868680"/>
-          </a:xfrm>
-          <a:prstGeom prst="rect">
-            <a:avLst/>
-          </a:prstGeom>
-          <a:solidFill>
-            <a:srgbClr val="F8F9FA"/>
-          </a:solidFill>
-          <a:ln w="12700">
-            <a:solidFill>
-              <a:srgbClr val="E0E0E0"/>
-            </a:solidFill>
-            <a:prstDash val="solid"/>
-          </a:ln>
-        </p:spPr>
-      </p:sp>
-      <p:sp>
-        <p:nvSpPr>
-          <p:cNvPr id="11" name="Text 9"/>
-          <p:cNvSpPr/>
-          <p:nvPr/>
-        </p:nvSpPr>
-        <p:spPr>
-          <a:xfrm>
-            <a:off x="640080" y="1737360"/>
-            <a:ext cx="7863840" cy="228600"/>
-          </a:xfrm>
-          <a:prstGeom prst="rect">
-            <a:avLst/>
-          </a:prstGeom>
-          <a:noFill/>
-          <a:ln/>
-        </p:spPr>
-        <p:txBody>
-          <a:bodyPr wrap="square" rtlCol="0" anchor="ctr"/>
-          <a:lstStyle/>
-          <a:p>
-            <a:pPr indent="0" marL="0">
-              <a:buNone/>
-            </a:pPr>
-            <a:r>
-              <a:rPr lang="en-US" sz="900" b="1" dirty="0">
-                <a:solidFill>
-                  <a:srgbClr val="1976D2"/>
-                </a:solidFill>
-                <a:latin typeface="Arial" pitchFamily="34" charset="0"/>
-                <a:ea typeface="Arial" pitchFamily="34" charset="-122"/>
-                <a:cs typeface="Arial" pitchFamily="34" charset="-120"/>
-              </a:rPr>
-              <a:t>Q1: How do you handle dynamic typing in Python?</a:t>
-            </a:r>
-            <a:endParaRPr lang="en-US" sz="900" dirty="0"/>
-          </a:p>
-        </p:txBody>
-      </p:sp>
-      <p:sp>
-        <p:nvSpPr>
-          <p:cNvPr id="12" name="Text 10"/>
-          <p:cNvSpPr/>
-          <p:nvPr/>
-        </p:nvSpPr>
-        <p:spPr>
-          <a:xfrm>
-            <a:off x="640080" y="1965960"/>
-            <a:ext cx="7863840" cy="502920"/>
-          </a:xfrm>
-          <a:prstGeom prst="rect">
-            <a:avLst/>
-          </a:prstGeom>
-          <a:noFill/>
-          <a:ln/>
-        </p:spPr>
-        <p:txBody>
-          <a:bodyPr wrap="square" rtlCol="0" anchor="ctr"/>
-          <a:lstStyle/>
-          <a:p>
-            <a:pPr indent="0" marL="0">
-              <a:lnSpc>
-                <a:spcPts val="1100"/>
-              </a:lnSpc>
-              <a:buNone/>
-            </a:pPr>
-            <a:r>
-              <a:rPr lang="en-US" sz="780" dirty="0">
-                <a:solidFill>
-                  <a:srgbClr val="333333"/>
-                </a:solidFill>
-                <a:latin typeface="Arial" pitchFamily="34" charset="0"/>
-                <a:ea typeface="Arial" pitchFamily="34" charset="-122"/>
-                <a:cs typeface="Arial" pitchFamily="34" charset="-120"/>
-              </a:rPr>
-              <a:t>We target 70% dataflow coverage rather than claiming full mathematical soundness. We use constant propagation and typeshed stubs; unresolvable sites are placed in an explicit audit bucket rather than guessed.</a:t>
-            </a:r>
-            <a:endParaRPr lang="en-US" sz="780" dirty="0"/>
-          </a:p>
-        </p:txBody>
-      </p:sp>
-      <p:sp>
-        <p:nvSpPr>
-          <p:cNvPr id="13" name="Shape 11"/>
-          <p:cNvSpPr/>
-          <p:nvPr/>
-        </p:nvSpPr>
-        <p:spPr>
-          <a:xfrm>
-            <a:off x="457200" y="2606040"/>
-            <a:ext cx="8229600" cy="868680"/>
-          </a:xfrm>
-          <a:prstGeom prst="rect">
-            <a:avLst/>
-          </a:prstGeom>
-          <a:solidFill>
-            <a:srgbClr val="F8F9FA"/>
-          </a:solidFill>
-          <a:ln w="12700">
-            <a:solidFill>
-              <a:srgbClr val="E0E0E0"/>
-            </a:solidFill>
-            <a:prstDash val="solid"/>
-          </a:ln>
-        </p:spPr>
-      </p:sp>
-      <p:sp>
-        <p:nvSpPr>
-          <p:cNvPr id="14" name="Text 12"/>
-          <p:cNvSpPr/>
-          <p:nvPr/>
-        </p:nvSpPr>
-        <p:spPr>
-          <a:xfrm>
-            <a:off x="640080" y="2697480"/>
-            <a:ext cx="7863840" cy="228600"/>
-          </a:xfrm>
-          <a:prstGeom prst="rect">
-            <a:avLst/>
-          </a:prstGeom>
-          <a:noFill/>
-          <a:ln/>
-        </p:spPr>
-        <p:txBody>
-          <a:bodyPr wrap="square" rtlCol="0" anchor="ctr"/>
-          <a:lstStyle/>
-          <a:p>
-            <a:pPr indent="0" marL="0">
-              <a:buNone/>
-            </a:pPr>
-            <a:r>
-              <a:rPr lang="en-US" sz="900" b="1" dirty="0">
-                <a:solidFill>
-                  <a:srgbClr val="1976D2"/>
-                </a:solidFill>
-                <a:latin typeface="Arial" pitchFamily="34" charset="0"/>
-                <a:ea typeface="Arial" pitchFamily="34" charset="-122"/>
-                <a:cs typeface="Arial" pitchFamily="34" charset="-120"/>
-              </a:rPr>
-              <a:t>Q2: Why not use algorithm-severity scores like Shaw [P2]?</a:t>
-            </a:r>
-            <a:endParaRPr lang="en-US" sz="900" dirty="0"/>
-          </a:p>
-        </p:txBody>
-      </p:sp>
-      <p:sp>
-        <p:nvSpPr>
-          <p:cNvPr id="15" name="Text 13"/>
-          <p:cNvSpPr/>
-          <p:nvPr/>
-        </p:nvSpPr>
-        <p:spPr>
-          <a:xfrm>
-            <a:off x="640080" y="2926080"/>
-            <a:ext cx="7863840" cy="502920"/>
-          </a:xfrm>
-          <a:prstGeom prst="rect">
-            <a:avLst/>
-          </a:prstGeom>
-          <a:noFill/>
-          <a:ln/>
-        </p:spPr>
-        <p:txBody>
-          <a:bodyPr wrap="square" rtlCol="0" anchor="ctr"/>
-          <a:lstStyle/>
-          <a:p>
-            <a:pPr indent="0" marL="0">
-              <a:lnSpc>
-                <a:spcPts val="1100"/>
-              </a:lnSpc>
-              <a:buNone/>
-            </a:pPr>
-            <a:r>
-              <a:rPr lang="en-US" sz="780" dirty="0">
-                <a:solidFill>
-                  <a:srgbClr val="333333"/>
-                </a:solidFill>
-                <a:latin typeface="Arial" pitchFamily="34" charset="0"/>
-                <a:ea typeface="Arial" pitchFamily="34" charset="-122"/>
-                <a:cs typeface="Arial" pitchFamily="34" charset="-120"/>
-              </a:rPr>
-              <a:t>Shaw's score is algorithm-intrinsic; all RSA-2048 sites receive identical scores. Only dataflow-derived retention distinguishes 10-year S3 archives (breached) from 15-minute tokens (low risk).</a:t>
-            </a:r>
-            <a:endParaRPr lang="en-US" sz="780" dirty="0"/>
-          </a:p>
-        </p:txBody>
-      </p:sp>
-      <p:sp>
-        <p:nvSpPr>
-          <p:cNvPr id="16" name="Shape 14"/>
-          <p:cNvSpPr/>
-          <p:nvPr/>
-        </p:nvSpPr>
-        <p:spPr>
-          <a:xfrm>
-            <a:off x="457200" y="3566160"/>
-            <a:ext cx="8229600" cy="868680"/>
-          </a:xfrm>
-          <a:prstGeom prst="rect">
-            <a:avLst/>
-          </a:prstGeom>
-          <a:solidFill>
-            <a:srgbClr val="F8F9FA"/>
-          </a:solidFill>
-          <a:ln w="12700">
-            <a:solidFill>
-              <a:srgbClr val="E0E0E0"/>
-            </a:solidFill>
-            <a:prstDash val="solid"/>
-          </a:ln>
-        </p:spPr>
-      </p:sp>
-      <p:sp>
-        <p:nvSpPr>
-          <p:cNvPr id="17" name="Text 15"/>
-          <p:cNvSpPr/>
-          <p:nvPr/>
-        </p:nvSpPr>
-        <p:spPr>
-          <a:xfrm>
-            <a:off x="640080" y="3657600"/>
-            <a:ext cx="7863840" cy="228600"/>
-          </a:xfrm>
-          <a:prstGeom prst="rect">
-            <a:avLst/>
-          </a:prstGeom>
-          <a:noFill/>
-          <a:ln/>
-        </p:spPr>
-        <p:txBody>
-          <a:bodyPr wrap="square" rtlCol="0" anchor="ctr"/>
-          <a:lstStyle/>
-          <a:p>
-            <a:pPr indent="0" marL="0">
-              <a:buNone/>
-            </a:pPr>
-            <a:r>
-              <a:rPr lang="en-US" sz="900" b="1" dirty="0">
-                <a:solidFill>
-                  <a:srgbClr val="1976D2"/>
-                </a:solidFill>
-                <a:latin typeface="Arial" pitchFamily="34" charset="0"/>
-                <a:ea typeface="Arial" pitchFamily="34" charset="-122"/>
-                <a:cs typeface="Arial" pitchFamily="34" charset="-120"/>
-              </a:rPr>
-              <a:t>Q3: How do you guarantee PQC patches don't break code?</a:t>
-            </a:r>
-            <a:endParaRPr lang="en-US" sz="900" dirty="0"/>
-          </a:p>
-        </p:txBody>
-      </p:sp>
-      <p:sp>
-        <p:nvSpPr>
-          <p:cNvPr id="18" name="Text 16"/>
-          <p:cNvSpPr/>
-          <p:nvPr/>
-        </p:nvSpPr>
-        <p:spPr>
-          <a:xfrm>
-            <a:off x="640080" y="3886200"/>
-            <a:ext cx="7863840" cy="502920"/>
-          </a:xfrm>
-          <a:prstGeom prst="rect">
-            <a:avLst/>
-          </a:prstGeom>
-          <a:noFill/>
-          <a:ln/>
-        </p:spPr>
-        <p:txBody>
-          <a:bodyPr wrap="square" rtlCol="0" anchor="ctr"/>
-          <a:lstStyle/>
-          <a:p>
-            <a:pPr indent="0" marL="0">
-              <a:lnSpc>
-                <a:spcPts val="1100"/>
-              </a:lnSpc>
-              <a:buNone/>
-            </a:pPr>
-            <a:r>
-              <a:rPr lang="en-US" sz="780" dirty="0">
-                <a:solidFill>
-                  <a:srgbClr val="333333"/>
-                </a:solidFill>
-                <a:latin typeface="Arial" pitchFamily="34" charset="0"/>
-                <a:ea typeface="Arial" pitchFamily="34" charset="-122"/>
-                <a:cs typeface="Arial" pitchFamily="34" charset="-120"/>
-              </a:rPr>
-              <a:t>We use verified hybrid templates (X25519+ML-KEM) via liboqs, gated by differential equivalence testing on identical inputs, property tests for wrong-key failure, and downgrade resilience checks.</a:t>
-            </a:r>
-            <a:endParaRPr lang="en-US" sz="780" dirty="0"/>
           </a:p>
         </p:txBody>
       </p:sp>
@@ -29705,7 +28986,7 @@
                 <a:ea typeface="Arial" pitchFamily="34" charset="-122"/>
                 <a:cs typeface="Arial" pitchFamily="34" charset="-120"/>
               </a:rPr>
-              <a:t>04 / 37</a:t>
+              <a:t>04 / 36</a:t>
             </a:r>
             <a:endParaRPr lang="en-US" sz="850" dirty="0"/>
           </a:p>
@@ -30445,7 +29726,7 @@
                 <a:ea typeface="Arial" pitchFamily="34" charset="-122"/>
                 <a:cs typeface="Arial" pitchFamily="34" charset="-120"/>
               </a:rPr>
-              <a:t>05 / 37</a:t>
+              <a:t>05 / 36</a:t>
             </a:r>
             <a:endParaRPr lang="en-US" sz="850" dirty="0"/>
           </a:p>
@@ -31149,7 +30430,7 @@
                 <a:ea typeface="Arial" pitchFamily="34" charset="-122"/>
                 <a:cs typeface="Arial" pitchFamily="34" charset="-120"/>
               </a:rPr>
-              <a:t>06 / 37</a:t>
+              <a:t>06 / 36</a:t>
             </a:r>
             <a:endParaRPr lang="en-US" sz="850" dirty="0"/>
           </a:p>
@@ -31889,7 +31170,7 @@
                 <a:ea typeface="Arial" pitchFamily="34" charset="-122"/>
                 <a:cs typeface="Arial" pitchFamily="34" charset="-120"/>
               </a:rPr>
-              <a:t>07 / 37</a:t>
+              <a:t>07 / 36</a:t>
             </a:r>
             <a:endParaRPr lang="en-US" sz="850" dirty="0"/>
           </a:p>
@@ -32781,7 +32062,7 @@
                 <a:ea typeface="Arial" pitchFamily="34" charset="-122"/>
                 <a:cs typeface="Arial" pitchFamily="34" charset="-120"/>
               </a:rPr>
-              <a:t>08 / 37</a:t>
+              <a:t>08 / 36</a:t>
             </a:r>
             <a:endParaRPr lang="en-US" sz="850" dirty="0"/>
           </a:p>
@@ -33371,7 +32652,7 @@
                 <a:ea typeface="Arial" pitchFamily="34" charset="-122"/>
                 <a:cs typeface="Arial" pitchFamily="34" charset="-120"/>
               </a:rPr>
-              <a:t>09 / 37</a:t>
+              <a:t>09 / 36</a:t>
             </a:r>
             <a:endParaRPr lang="en-US" sz="850" dirty="0"/>
           </a:p>

</xml_diff>

<commit_message>
style: apply crisp light theme to PPT generator
</commit_message>
<xml_diff>
--- a/docs/presentations/Crypto-Agility_Navigator_Review2.pptx
+++ b/docs/presentations/Crypto-Agility_Navigator_Review2.pptx
@@ -2993,7 +2993,7 @@
     <p:bg>
       <p:bgPr>
         <a:solidFill>
-          <a:srgbClr val="0B0F19"/>
+          <a:srgbClr val="F8FAFC"/>
         </a:solidFill>
       </p:bgPr>
     </p:bg>
@@ -3038,7 +3038,7 @@
             <a:r>
               <a:rPr lang="en-US" sz="3200" b="1" dirty="0">
                 <a:solidFill>
-                  <a:srgbClr val="3B82F6"/>
+                  <a:srgbClr val="2563EB"/>
                 </a:solidFill>
                 <a:latin typeface="Arial" pitchFamily="34" charset="0"/>
                 <a:ea typeface="Arial" pitchFamily="34" charset="-122"/>
@@ -3077,7 +3077,7 @@
             <a:r>
               <a:rPr lang="en-US" sz="1800" b="1" dirty="0">
                 <a:solidFill>
-                  <a:srgbClr val="F8FAFC"/>
+                  <a:srgbClr val="0F172A"/>
                 </a:solidFill>
                 <a:latin typeface="Arial" pitchFamily="34" charset="0"/>
                 <a:ea typeface="Arial" pitchFamily="34" charset="-122"/>
@@ -3119,7 +3119,7 @@
             <a:r>
               <a:rPr lang="en-US" sz="1200" b="1" dirty="0">
                 <a:solidFill>
-                  <a:srgbClr val="94A3B8"/>
+                  <a:srgbClr val="334155"/>
                 </a:solidFill>
                 <a:latin typeface="Arial" pitchFamily="34" charset="0"/>
                 <a:ea typeface="Arial" pitchFamily="34" charset="-122"/>
@@ -3181,7 +3181,7 @@
     <p:bg>
       <p:bgPr>
         <a:solidFill>
-          <a:srgbClr val="0B0F19"/>
+          <a:srgbClr val="F8FAFC"/>
         </a:solidFill>
       </p:bgPr>
     </p:bg>
@@ -3216,7 +3216,7 @@
           <a:noFill/>
           <a:ln w="12700">
             <a:solidFill>
-              <a:srgbClr val="2A3B5C"/>
+              <a:srgbClr val="E2E8F0"/>
             </a:solidFill>
             <a:prstDash val="solid"/>
           </a:ln>
@@ -3366,7 +3366,7 @@
             <a:r>
               <a:rPr lang="en-US" sz="1800" b="1" dirty="0">
                 <a:solidFill>
-                  <a:srgbClr val="F8FAFC"/>
+                  <a:srgbClr val="0F172A"/>
                 </a:solidFill>
                 <a:latin typeface="Arial" pitchFamily="34" charset="0"/>
                 <a:ea typeface="Arial" pitchFamily="34" charset="-122"/>
@@ -3395,7 +3395,7 @@
           <a:noFill/>
           <a:ln w="12700">
             <a:solidFill>
-              <a:srgbClr val="2A3B5C"/>
+              <a:srgbClr val="E2E8F0"/>
             </a:solidFill>
             <a:prstDash val="solid"/>
           </a:ln>
@@ -3494,11 +3494,11 @@
             <a:avLst/>
           </a:prstGeom>
           <a:solidFill>
-            <a:srgbClr val="131B2B"/>
+            <a:srgbClr val="FFFFFF"/>
           </a:solidFill>
           <a:ln w="12700">
             <a:solidFill>
-              <a:srgbClr val="2A3B5C"/>
+              <a:srgbClr val="E2E8F0"/>
             </a:solidFill>
             <a:prstDash val="solid"/>
           </a:ln>
@@ -3534,7 +3534,7 @@
             <a:r>
               <a:rPr lang="en-US" sz="1000" dirty="0">
                 <a:solidFill>
-                  <a:srgbClr val="F8FAFC"/>
+                  <a:srgbClr val="0F172A"/>
                 </a:solidFill>
                 <a:latin typeface="Courier" pitchFamily="34" charset="0"/>
                 <a:ea typeface="Courier" pitchFamily="34" charset="-122"/>
@@ -3554,7 +3554,7 @@
             <a:r>
               <a:rPr lang="en-US" sz="1000" dirty="0">
                 <a:solidFill>
-                  <a:srgbClr val="F8FAFC"/>
+                  <a:srgbClr val="0F172A"/>
                 </a:solidFill>
                 <a:latin typeface="Courier" pitchFamily="34" charset="0"/>
                 <a:ea typeface="Courier" pitchFamily="34" charset="-122"/>
@@ -3574,7 +3574,7 @@
             <a:r>
               <a:rPr lang="en-US" sz="1000" dirty="0">
                 <a:solidFill>
-                  <a:srgbClr val="F8FAFC"/>
+                  <a:srgbClr val="0F172A"/>
                 </a:solidFill>
                 <a:latin typeface="Courier" pitchFamily="34" charset="0"/>
                 <a:ea typeface="Courier" pitchFamily="34" charset="-122"/>
@@ -3594,7 +3594,7 @@
             <a:r>
               <a:rPr lang="en-US" sz="1000" dirty="0">
                 <a:solidFill>
-                  <a:srgbClr val="F8FAFC"/>
+                  <a:srgbClr val="0F172A"/>
                 </a:solidFill>
                 <a:latin typeface="Courier" pitchFamily="34" charset="0"/>
                 <a:ea typeface="Courier" pitchFamily="34" charset="-122"/>
@@ -3614,7 +3614,7 @@
             <a:r>
               <a:rPr lang="en-US" sz="1000" dirty="0">
                 <a:solidFill>
-                  <a:srgbClr val="F8FAFC"/>
+                  <a:srgbClr val="0F172A"/>
                 </a:solidFill>
                 <a:latin typeface="Courier" pitchFamily="34" charset="0"/>
                 <a:ea typeface="Courier" pitchFamily="34" charset="-122"/>
@@ -3640,7 +3640,7 @@
     <p:bg>
       <p:bgPr>
         <a:solidFill>
-          <a:srgbClr val="0B0F19"/>
+          <a:srgbClr val="F8FAFC"/>
         </a:solidFill>
       </p:bgPr>
     </p:bg>
@@ -3675,7 +3675,7 @@
           <a:noFill/>
           <a:ln w="12700">
             <a:solidFill>
-              <a:srgbClr val="2A3B5C"/>
+              <a:srgbClr val="E2E8F0"/>
             </a:solidFill>
             <a:prstDash val="solid"/>
           </a:ln>
@@ -3825,7 +3825,7 @@
             <a:r>
               <a:rPr lang="en-US" sz="1800" b="1" dirty="0">
                 <a:solidFill>
-                  <a:srgbClr val="F8FAFC"/>
+                  <a:srgbClr val="0F172A"/>
                 </a:solidFill>
                 <a:latin typeface="Arial" pitchFamily="34" charset="0"/>
                 <a:ea typeface="Arial" pitchFamily="34" charset="-122"/>
@@ -3854,7 +3854,7 @@
           <a:noFill/>
           <a:ln w="12700">
             <a:solidFill>
-              <a:srgbClr val="2A3B5C"/>
+              <a:srgbClr val="E2E8F0"/>
             </a:solidFill>
             <a:prstDash val="solid"/>
           </a:ln>
@@ -3953,11 +3953,11 @@
             <a:avLst/>
           </a:prstGeom>
           <a:solidFill>
-            <a:srgbClr val="131B2B"/>
+            <a:srgbClr val="FFFFFF"/>
           </a:solidFill>
           <a:ln w="12700">
             <a:solidFill>
-              <a:srgbClr val="2A3B5C"/>
+              <a:srgbClr val="E2E8F0"/>
             </a:solidFill>
             <a:prstDash val="solid"/>
           </a:ln>
@@ -3993,7 +3993,7 @@
             <a:r>
               <a:rPr lang="en-US" sz="1000" dirty="0">
                 <a:solidFill>
-                  <a:srgbClr val="F8FAFC"/>
+                  <a:srgbClr val="0F172A"/>
                 </a:solidFill>
                 <a:latin typeface="Courier" pitchFamily="34" charset="0"/>
                 <a:ea typeface="Courier" pitchFamily="34" charset="-122"/>
@@ -4022,7 +4022,7 @@
             <a:r>
               <a:rPr lang="en-US" sz="1000" dirty="0">
                 <a:solidFill>
-                  <a:srgbClr val="F8FAFC"/>
+                  <a:srgbClr val="0F172A"/>
                 </a:solidFill>
                 <a:latin typeface="Courier" pitchFamily="34" charset="0"/>
                 <a:ea typeface="Courier" pitchFamily="34" charset="-122"/>
@@ -4042,7 +4042,7 @@
             <a:r>
               <a:rPr lang="en-US" sz="1000" dirty="0">
                 <a:solidFill>
-                  <a:srgbClr val="F8FAFC"/>
+                  <a:srgbClr val="0F172A"/>
                 </a:solidFill>
                 <a:latin typeface="Courier" pitchFamily="34" charset="0"/>
                 <a:ea typeface="Courier" pitchFamily="34" charset="-122"/>
@@ -4062,7 +4062,7 @@
             <a:r>
               <a:rPr lang="en-US" sz="1000" dirty="0">
                 <a:solidFill>
-                  <a:srgbClr val="F8FAFC"/>
+                  <a:srgbClr val="0F172A"/>
                 </a:solidFill>
                 <a:latin typeface="Courier" pitchFamily="34" charset="0"/>
                 <a:ea typeface="Courier" pitchFamily="34" charset="-122"/>
@@ -4082,7 +4082,7 @@
             <a:r>
               <a:rPr lang="en-US" sz="1000" dirty="0">
                 <a:solidFill>
-                  <a:srgbClr val="F8FAFC"/>
+                  <a:srgbClr val="0F172A"/>
                 </a:solidFill>
                 <a:latin typeface="Courier" pitchFamily="34" charset="0"/>
                 <a:ea typeface="Courier" pitchFamily="34" charset="-122"/>
@@ -4102,7 +4102,7 @@
             <a:r>
               <a:rPr lang="en-US" sz="1000" dirty="0">
                 <a:solidFill>
-                  <a:srgbClr val="F8FAFC"/>
+                  <a:srgbClr val="0F172A"/>
                 </a:solidFill>
                 <a:latin typeface="Courier" pitchFamily="34" charset="0"/>
                 <a:ea typeface="Courier" pitchFamily="34" charset="-122"/>
@@ -4122,7 +4122,7 @@
             <a:r>
               <a:rPr lang="en-US" sz="1000" dirty="0">
                 <a:solidFill>
-                  <a:srgbClr val="F8FAFC"/>
+                  <a:srgbClr val="0F172A"/>
                 </a:solidFill>
                 <a:latin typeface="Courier" pitchFamily="34" charset="0"/>
                 <a:ea typeface="Courier" pitchFamily="34" charset="-122"/>
@@ -4142,7 +4142,7 @@
             <a:r>
               <a:rPr lang="en-US" sz="1000" dirty="0">
                 <a:solidFill>
-                  <a:srgbClr val="F8FAFC"/>
+                  <a:srgbClr val="0F172A"/>
                 </a:solidFill>
                 <a:latin typeface="Courier" pitchFamily="34" charset="0"/>
                 <a:ea typeface="Courier" pitchFamily="34" charset="-122"/>
@@ -4168,7 +4168,7 @@
     <p:bg>
       <p:bgPr>
         <a:solidFill>
-          <a:srgbClr val="0B0F19"/>
+          <a:srgbClr val="F8FAFC"/>
         </a:solidFill>
       </p:bgPr>
     </p:bg>
@@ -4203,7 +4203,7 @@
           <a:noFill/>
           <a:ln w="12700">
             <a:solidFill>
-              <a:srgbClr val="2A3B5C"/>
+              <a:srgbClr val="E2E8F0"/>
             </a:solidFill>
             <a:prstDash val="solid"/>
           </a:ln>
@@ -4353,7 +4353,7 @@
             <a:r>
               <a:rPr lang="en-US" sz="1800" b="1" dirty="0">
                 <a:solidFill>
-                  <a:srgbClr val="F8FAFC"/>
+                  <a:srgbClr val="0F172A"/>
                 </a:solidFill>
                 <a:latin typeface="Arial" pitchFamily="34" charset="0"/>
                 <a:ea typeface="Arial" pitchFamily="34" charset="-122"/>
@@ -4382,7 +4382,7 @@
           <a:noFill/>
           <a:ln w="12700">
             <a:solidFill>
-              <a:srgbClr val="2A3B5C"/>
+              <a:srgbClr val="E2E8F0"/>
             </a:solidFill>
             <a:prstDash val="solid"/>
           </a:ln>
@@ -4481,11 +4481,11 @@
             <a:avLst/>
           </a:prstGeom>
           <a:solidFill>
-            <a:srgbClr val="131B2B"/>
+            <a:srgbClr val="FFFFFF"/>
           </a:solidFill>
           <a:ln w="12700">
             <a:solidFill>
-              <a:srgbClr val="2A3B5C"/>
+              <a:srgbClr val="E2E8F0"/>
             </a:solidFill>
             <a:prstDash val="solid"/>
           </a:ln>
@@ -4521,7 +4521,7 @@
             <a:r>
               <a:rPr lang="en-US" sz="1000" dirty="0">
                 <a:solidFill>
-                  <a:srgbClr val="F8FAFC"/>
+                  <a:srgbClr val="0F172A"/>
                 </a:solidFill>
                 <a:latin typeface="Courier" pitchFamily="34" charset="0"/>
                 <a:ea typeface="Courier" pitchFamily="34" charset="-122"/>
@@ -4541,7 +4541,7 @@
             <a:r>
               <a:rPr lang="en-US" sz="1000" dirty="0">
                 <a:solidFill>
-                  <a:srgbClr val="F8FAFC"/>
+                  <a:srgbClr val="0F172A"/>
                 </a:solidFill>
                 <a:latin typeface="Courier" pitchFamily="34" charset="0"/>
                 <a:ea typeface="Courier" pitchFamily="34" charset="-122"/>
@@ -4561,7 +4561,7 @@
             <a:r>
               <a:rPr lang="en-US" sz="1000" dirty="0">
                 <a:solidFill>
-                  <a:srgbClr val="F8FAFC"/>
+                  <a:srgbClr val="0F172A"/>
                 </a:solidFill>
                 <a:latin typeface="Courier" pitchFamily="34" charset="0"/>
                 <a:ea typeface="Courier" pitchFamily="34" charset="-122"/>
@@ -4581,7 +4581,7 @@
             <a:r>
               <a:rPr lang="en-US" sz="1000" dirty="0">
                 <a:solidFill>
-                  <a:srgbClr val="F8FAFC"/>
+                  <a:srgbClr val="0F172A"/>
                 </a:solidFill>
                 <a:latin typeface="Courier" pitchFamily="34" charset="0"/>
                 <a:ea typeface="Courier" pitchFamily="34" charset="-122"/>
@@ -4601,7 +4601,7 @@
             <a:r>
               <a:rPr lang="en-US" sz="1000" dirty="0">
                 <a:solidFill>
-                  <a:srgbClr val="F8FAFC"/>
+                  <a:srgbClr val="0F172A"/>
                 </a:solidFill>
                 <a:latin typeface="Courier" pitchFamily="34" charset="0"/>
                 <a:ea typeface="Courier" pitchFamily="34" charset="-122"/>
@@ -4621,7 +4621,7 @@
             <a:r>
               <a:rPr lang="en-US" sz="1000" dirty="0">
                 <a:solidFill>
-                  <a:srgbClr val="F8FAFC"/>
+                  <a:srgbClr val="0F172A"/>
                 </a:solidFill>
                 <a:latin typeface="Courier" pitchFamily="34" charset="0"/>
                 <a:ea typeface="Courier" pitchFamily="34" charset="-122"/>
@@ -4647,7 +4647,7 @@
     <p:bg>
       <p:bgPr>
         <a:solidFill>
-          <a:srgbClr val="0B0F19"/>
+          <a:srgbClr val="F8FAFC"/>
         </a:solidFill>
       </p:bgPr>
     </p:bg>
@@ -4682,7 +4682,7 @@
           <a:noFill/>
           <a:ln w="12700">
             <a:solidFill>
-              <a:srgbClr val="2A3B5C"/>
+              <a:srgbClr val="E2E8F0"/>
             </a:solidFill>
             <a:prstDash val="solid"/>
           </a:ln>
@@ -4832,7 +4832,7 @@
             <a:r>
               <a:rPr lang="en-US" sz="1800" b="1" dirty="0">
                 <a:solidFill>
-                  <a:srgbClr val="F8FAFC"/>
+                  <a:srgbClr val="0F172A"/>
                 </a:solidFill>
                 <a:latin typeface="Arial" pitchFamily="34" charset="0"/>
                 <a:ea typeface="Arial" pitchFamily="34" charset="-122"/>
@@ -4861,7 +4861,7 @@
           <a:noFill/>
           <a:ln w="12700">
             <a:solidFill>
-              <a:srgbClr val="2A3B5C"/>
+              <a:srgbClr val="E2E8F0"/>
             </a:solidFill>
             <a:prstDash val="solid"/>
           </a:ln>
@@ -4960,11 +4960,11 @@
             <a:avLst/>
           </a:prstGeom>
           <a:solidFill>
-            <a:srgbClr val="131B2B"/>
+            <a:srgbClr val="FFFFFF"/>
           </a:solidFill>
           <a:ln w="12700">
             <a:solidFill>
-              <a:srgbClr val="2A3B5C"/>
+              <a:srgbClr val="E2E8F0"/>
             </a:solidFill>
             <a:prstDash val="solid"/>
           </a:ln>
@@ -5000,7 +5000,7 @@
             <a:r>
               <a:rPr lang="en-US" sz="1000" dirty="0">
                 <a:solidFill>
-                  <a:srgbClr val="F8FAFC"/>
+                  <a:srgbClr val="0F172A"/>
                 </a:solidFill>
                 <a:latin typeface="Courier" pitchFamily="34" charset="0"/>
                 <a:ea typeface="Courier" pitchFamily="34" charset="-122"/>
@@ -5029,7 +5029,7 @@
             <a:r>
               <a:rPr lang="en-US" sz="1000" dirty="0">
                 <a:solidFill>
-                  <a:srgbClr val="F8FAFC"/>
+                  <a:srgbClr val="0F172A"/>
                 </a:solidFill>
                 <a:latin typeface="Courier" pitchFamily="34" charset="0"/>
                 <a:ea typeface="Courier" pitchFamily="34" charset="-122"/>
@@ -5049,7 +5049,7 @@
             <a:r>
               <a:rPr lang="en-US" sz="1000" dirty="0">
                 <a:solidFill>
-                  <a:srgbClr val="F8FAFC"/>
+                  <a:srgbClr val="0F172A"/>
                 </a:solidFill>
                 <a:latin typeface="Courier" pitchFamily="34" charset="0"/>
                 <a:ea typeface="Courier" pitchFamily="34" charset="-122"/>
@@ -5069,7 +5069,7 @@
             <a:r>
               <a:rPr lang="en-US" sz="1000" dirty="0">
                 <a:solidFill>
-                  <a:srgbClr val="F8FAFC"/>
+                  <a:srgbClr val="0F172A"/>
                 </a:solidFill>
                 <a:latin typeface="Courier" pitchFamily="34" charset="0"/>
                 <a:ea typeface="Courier" pitchFamily="34" charset="-122"/>
@@ -5089,7 +5089,7 @@
             <a:r>
               <a:rPr lang="en-US" sz="1000" dirty="0">
                 <a:solidFill>
-                  <a:srgbClr val="F8FAFC"/>
+                  <a:srgbClr val="0F172A"/>
                 </a:solidFill>
                 <a:latin typeface="Courier" pitchFamily="34" charset="0"/>
                 <a:ea typeface="Courier" pitchFamily="34" charset="-122"/>
@@ -5115,7 +5115,7 @@
     <p:bg>
       <p:bgPr>
         <a:solidFill>
-          <a:srgbClr val="0B0F19"/>
+          <a:srgbClr val="F8FAFC"/>
         </a:solidFill>
       </p:bgPr>
     </p:bg>
@@ -5150,7 +5150,7 @@
           <a:noFill/>
           <a:ln w="12700">
             <a:solidFill>
-              <a:srgbClr val="2A3B5C"/>
+              <a:srgbClr val="E2E8F0"/>
             </a:solidFill>
             <a:prstDash val="solid"/>
           </a:ln>
@@ -5300,7 +5300,7 @@
             <a:r>
               <a:rPr lang="en-US" sz="1800" b="1" dirty="0">
                 <a:solidFill>
-                  <a:srgbClr val="F8FAFC"/>
+                  <a:srgbClr val="0F172A"/>
                 </a:solidFill>
                 <a:latin typeface="Arial" pitchFamily="34" charset="0"/>
                 <a:ea typeface="Arial" pitchFamily="34" charset="-122"/>
@@ -5329,7 +5329,7 @@
           <a:noFill/>
           <a:ln w="12700">
             <a:solidFill>
-              <a:srgbClr val="2A3B5C"/>
+              <a:srgbClr val="E2E8F0"/>
             </a:solidFill>
             <a:prstDash val="solid"/>
           </a:ln>
@@ -5428,11 +5428,11 @@
             <a:avLst/>
           </a:prstGeom>
           <a:solidFill>
-            <a:srgbClr val="131B2B"/>
+            <a:srgbClr val="FFFFFF"/>
           </a:solidFill>
           <a:ln w="12700">
             <a:solidFill>
-              <a:srgbClr val="2A3B5C"/>
+              <a:srgbClr val="E2E8F0"/>
             </a:solidFill>
             <a:prstDash val="solid"/>
           </a:ln>
@@ -5468,7 +5468,7 @@
             <a:r>
               <a:rPr lang="en-US" sz="1000" dirty="0">
                 <a:solidFill>
-                  <a:srgbClr val="F8FAFC"/>
+                  <a:srgbClr val="0F172A"/>
                 </a:solidFill>
                 <a:latin typeface="Courier" pitchFamily="34" charset="0"/>
                 <a:ea typeface="Courier" pitchFamily="34" charset="-122"/>
@@ -5488,7 +5488,7 @@
             <a:r>
               <a:rPr lang="en-US" sz="1000" dirty="0">
                 <a:solidFill>
-                  <a:srgbClr val="F8FAFC"/>
+                  <a:srgbClr val="0F172A"/>
                 </a:solidFill>
                 <a:latin typeface="Courier" pitchFamily="34" charset="0"/>
                 <a:ea typeface="Courier" pitchFamily="34" charset="-122"/>
@@ -5508,7 +5508,7 @@
             <a:r>
               <a:rPr lang="en-US" sz="1000" dirty="0">
                 <a:solidFill>
-                  <a:srgbClr val="F8FAFC"/>
+                  <a:srgbClr val="0F172A"/>
                 </a:solidFill>
                 <a:latin typeface="Courier" pitchFamily="34" charset="0"/>
                 <a:ea typeface="Courier" pitchFamily="34" charset="-122"/>
@@ -5528,7 +5528,7 @@
             <a:r>
               <a:rPr lang="en-US" sz="1000" dirty="0">
                 <a:solidFill>
-                  <a:srgbClr val="F8FAFC"/>
+                  <a:srgbClr val="0F172A"/>
                 </a:solidFill>
                 <a:latin typeface="Courier" pitchFamily="34" charset="0"/>
                 <a:ea typeface="Courier" pitchFamily="34" charset="-122"/>
@@ -5557,7 +5557,7 @@
             <a:r>
               <a:rPr lang="en-US" sz="1000" dirty="0">
                 <a:solidFill>
-                  <a:srgbClr val="F8FAFC"/>
+                  <a:srgbClr val="0F172A"/>
                 </a:solidFill>
                 <a:latin typeface="Courier" pitchFamily="34" charset="0"/>
                 <a:ea typeface="Courier" pitchFamily="34" charset="-122"/>
@@ -5577,7 +5577,7 @@
             <a:r>
               <a:rPr lang="en-US" sz="1000" dirty="0">
                 <a:solidFill>
-                  <a:srgbClr val="F8FAFC"/>
+                  <a:srgbClr val="0F172A"/>
                 </a:solidFill>
                 <a:latin typeface="Courier" pitchFamily="34" charset="0"/>
                 <a:ea typeface="Courier" pitchFamily="34" charset="-122"/>
@@ -5597,7 +5597,7 @@
             <a:r>
               <a:rPr lang="en-US" sz="1000" dirty="0">
                 <a:solidFill>
-                  <a:srgbClr val="F8FAFC"/>
+                  <a:srgbClr val="0F172A"/>
                 </a:solidFill>
                 <a:latin typeface="Courier" pitchFamily="34" charset="0"/>
                 <a:ea typeface="Courier" pitchFamily="34" charset="-122"/>
@@ -5617,7 +5617,7 @@
             <a:r>
               <a:rPr lang="en-US" sz="1000" dirty="0">
                 <a:solidFill>
-                  <a:srgbClr val="F8FAFC"/>
+                  <a:srgbClr val="0F172A"/>
                 </a:solidFill>
                 <a:latin typeface="Courier" pitchFamily="34" charset="0"/>
                 <a:ea typeface="Courier" pitchFamily="34" charset="-122"/>
@@ -5637,7 +5637,7 @@
             <a:r>
               <a:rPr lang="en-US" sz="1000" dirty="0">
                 <a:solidFill>
-                  <a:srgbClr val="F8FAFC"/>
+                  <a:srgbClr val="0F172A"/>
                 </a:solidFill>
                 <a:latin typeface="Courier" pitchFamily="34" charset="0"/>
                 <a:ea typeface="Courier" pitchFamily="34" charset="-122"/>
@@ -5663,7 +5663,7 @@
     <p:bg>
       <p:bgPr>
         <a:solidFill>
-          <a:srgbClr val="0B0F19"/>
+          <a:srgbClr val="F8FAFC"/>
         </a:solidFill>
       </p:bgPr>
     </p:bg>
@@ -5698,7 +5698,7 @@
           <a:noFill/>
           <a:ln w="12700">
             <a:solidFill>
-              <a:srgbClr val="2A3B5C"/>
+              <a:srgbClr val="E2E8F0"/>
             </a:solidFill>
             <a:prstDash val="solid"/>
           </a:ln>
@@ -5848,7 +5848,7 @@
             <a:r>
               <a:rPr lang="en-US" sz="1800" b="1" dirty="0">
                 <a:solidFill>
-                  <a:srgbClr val="F8FAFC"/>
+                  <a:srgbClr val="0F172A"/>
                 </a:solidFill>
                 <a:latin typeface="Arial" pitchFamily="34" charset="0"/>
                 <a:ea typeface="Arial" pitchFamily="34" charset="-122"/>
@@ -5877,7 +5877,7 @@
           <a:noFill/>
           <a:ln w="12700">
             <a:solidFill>
-              <a:srgbClr val="2A3B5C"/>
+              <a:srgbClr val="E2E8F0"/>
             </a:solidFill>
             <a:prstDash val="solid"/>
           </a:ln>
@@ -5976,11 +5976,11 @@
             <a:avLst/>
           </a:prstGeom>
           <a:solidFill>
-            <a:srgbClr val="131B2B"/>
+            <a:srgbClr val="FFFFFF"/>
           </a:solidFill>
           <a:ln w="12700">
             <a:solidFill>
-              <a:srgbClr val="2A3B5C"/>
+              <a:srgbClr val="E2E8F0"/>
             </a:solidFill>
             <a:prstDash val="solid"/>
           </a:ln>
@@ -6016,7 +6016,7 @@
             <a:r>
               <a:rPr lang="en-US" sz="1000" dirty="0">
                 <a:solidFill>
-                  <a:srgbClr val="F8FAFC"/>
+                  <a:srgbClr val="0F172A"/>
                 </a:solidFill>
                 <a:latin typeface="Courier" pitchFamily="34" charset="0"/>
                 <a:ea typeface="Courier" pitchFamily="34" charset="-122"/>
@@ -6036,7 +6036,7 @@
             <a:r>
               <a:rPr lang="en-US" sz="1000" dirty="0">
                 <a:solidFill>
-                  <a:srgbClr val="F8FAFC"/>
+                  <a:srgbClr val="0F172A"/>
                 </a:solidFill>
                 <a:latin typeface="Courier" pitchFamily="34" charset="0"/>
                 <a:ea typeface="Courier" pitchFamily="34" charset="-122"/>
@@ -6065,7 +6065,7 @@
             <a:r>
               <a:rPr lang="en-US" sz="1000" dirty="0">
                 <a:solidFill>
-                  <a:srgbClr val="F8FAFC"/>
+                  <a:srgbClr val="0F172A"/>
                 </a:solidFill>
                 <a:latin typeface="Courier" pitchFamily="34" charset="0"/>
                 <a:ea typeface="Courier" pitchFamily="34" charset="-122"/>
@@ -6085,7 +6085,7 @@
             <a:r>
               <a:rPr lang="en-US" sz="1000" dirty="0">
                 <a:solidFill>
-                  <a:srgbClr val="F8FAFC"/>
+                  <a:srgbClr val="0F172A"/>
                 </a:solidFill>
                 <a:latin typeface="Courier" pitchFamily="34" charset="0"/>
                 <a:ea typeface="Courier" pitchFamily="34" charset="-122"/>
@@ -6111,7 +6111,7 @@
     <p:bg>
       <p:bgPr>
         <a:solidFill>
-          <a:srgbClr val="0B0F19"/>
+          <a:srgbClr val="F8FAFC"/>
         </a:solidFill>
       </p:bgPr>
     </p:bg>
@@ -6146,7 +6146,7 @@
           <a:noFill/>
           <a:ln w="12700">
             <a:solidFill>
-              <a:srgbClr val="2A3B5C"/>
+              <a:srgbClr val="E2E8F0"/>
             </a:solidFill>
             <a:prstDash val="solid"/>
           </a:ln>
@@ -6296,7 +6296,7 @@
             <a:r>
               <a:rPr lang="en-US" sz="1800" b="1" dirty="0">
                 <a:solidFill>
-                  <a:srgbClr val="F8FAFC"/>
+                  <a:srgbClr val="0F172A"/>
                 </a:solidFill>
                 <a:latin typeface="Arial" pitchFamily="34" charset="0"/>
                 <a:ea typeface="Arial" pitchFamily="34" charset="-122"/>
@@ -6325,7 +6325,7 @@
           <a:noFill/>
           <a:ln w="12700">
             <a:solidFill>
-              <a:srgbClr val="2A3B5C"/>
+              <a:srgbClr val="E2E8F0"/>
             </a:solidFill>
             <a:prstDash val="solid"/>
           </a:ln>
@@ -6424,11 +6424,11 @@
             <a:avLst/>
           </a:prstGeom>
           <a:solidFill>
-            <a:srgbClr val="131B2B"/>
+            <a:srgbClr val="FFFFFF"/>
           </a:solidFill>
           <a:ln w="12700">
             <a:solidFill>
-              <a:srgbClr val="2A3B5C"/>
+              <a:srgbClr val="E2E8F0"/>
             </a:solidFill>
             <a:prstDash val="solid"/>
           </a:ln>
@@ -6464,7 +6464,7 @@
             <a:r>
               <a:rPr lang="en-US" sz="1000" dirty="0">
                 <a:solidFill>
-                  <a:srgbClr val="F8FAFC"/>
+                  <a:srgbClr val="0F172A"/>
                 </a:solidFill>
                 <a:latin typeface="Courier" pitchFamily="34" charset="0"/>
                 <a:ea typeface="Courier" pitchFamily="34" charset="-122"/>
@@ -6484,7 +6484,7 @@
             <a:r>
               <a:rPr lang="en-US" sz="1000" dirty="0">
                 <a:solidFill>
-                  <a:srgbClr val="F8FAFC"/>
+                  <a:srgbClr val="0F172A"/>
                 </a:solidFill>
                 <a:latin typeface="Courier" pitchFamily="34" charset="0"/>
                 <a:ea typeface="Courier" pitchFamily="34" charset="-122"/>
@@ -6504,7 +6504,7 @@
             <a:r>
               <a:rPr lang="en-US" sz="1000" dirty="0">
                 <a:solidFill>
-                  <a:srgbClr val="F8FAFC"/>
+                  <a:srgbClr val="0F172A"/>
                 </a:solidFill>
                 <a:latin typeface="Courier" pitchFamily="34" charset="0"/>
                 <a:ea typeface="Courier" pitchFamily="34" charset="-122"/>
@@ -6533,7 +6533,7 @@
             <a:r>
               <a:rPr lang="en-US" sz="1000" dirty="0">
                 <a:solidFill>
-                  <a:srgbClr val="F8FAFC"/>
+                  <a:srgbClr val="0F172A"/>
                 </a:solidFill>
                 <a:latin typeface="Courier" pitchFamily="34" charset="0"/>
                 <a:ea typeface="Courier" pitchFamily="34" charset="-122"/>
@@ -6553,7 +6553,7 @@
             <a:r>
               <a:rPr lang="en-US" sz="1000" dirty="0">
                 <a:solidFill>
-                  <a:srgbClr val="F8FAFC"/>
+                  <a:srgbClr val="0F172A"/>
                 </a:solidFill>
                 <a:latin typeface="Courier" pitchFamily="34" charset="0"/>
                 <a:ea typeface="Courier" pitchFamily="34" charset="-122"/>
@@ -6579,7 +6579,7 @@
     <p:bg>
       <p:bgPr>
         <a:solidFill>
-          <a:srgbClr val="0B0F19"/>
+          <a:srgbClr val="F8FAFC"/>
         </a:solidFill>
       </p:bgPr>
     </p:bg>
@@ -6614,7 +6614,7 @@
           <a:noFill/>
           <a:ln w="12700">
             <a:solidFill>
-              <a:srgbClr val="2A3B5C"/>
+              <a:srgbClr val="E2E8F0"/>
             </a:solidFill>
             <a:prstDash val="solid"/>
           </a:ln>
@@ -6764,7 +6764,7 @@
             <a:r>
               <a:rPr lang="en-US" sz="1800" b="1" dirty="0">
                 <a:solidFill>
-                  <a:srgbClr val="F8FAFC"/>
+                  <a:srgbClr val="0F172A"/>
                 </a:solidFill>
                 <a:latin typeface="Arial" pitchFamily="34" charset="0"/>
                 <a:ea typeface="Arial" pitchFamily="34" charset="-122"/>
@@ -6793,7 +6793,7 @@
           <a:noFill/>
           <a:ln w="12700">
             <a:solidFill>
-              <a:srgbClr val="2A3B5C"/>
+              <a:srgbClr val="E2E8F0"/>
             </a:solidFill>
             <a:prstDash val="solid"/>
           </a:ln>
@@ -6892,11 +6892,11 @@
             <a:avLst/>
           </a:prstGeom>
           <a:solidFill>
-            <a:srgbClr val="131B2B"/>
+            <a:srgbClr val="FFFFFF"/>
           </a:solidFill>
           <a:ln w="12700">
             <a:solidFill>
-              <a:srgbClr val="2A3B5C"/>
+              <a:srgbClr val="E2E8F0"/>
             </a:solidFill>
             <a:prstDash val="solid"/>
           </a:ln>
@@ -6932,7 +6932,7 @@
             <a:r>
               <a:rPr lang="en-US" sz="1000" dirty="0">
                 <a:solidFill>
-                  <a:srgbClr val="F8FAFC"/>
+                  <a:srgbClr val="0F172A"/>
                 </a:solidFill>
                 <a:latin typeface="Courier" pitchFamily="34" charset="0"/>
                 <a:ea typeface="Courier" pitchFamily="34" charset="-122"/>
@@ -6952,7 +6952,7 @@
             <a:r>
               <a:rPr lang="en-US" sz="1000" dirty="0">
                 <a:solidFill>
-                  <a:srgbClr val="F8FAFC"/>
+                  <a:srgbClr val="0F172A"/>
                 </a:solidFill>
                 <a:latin typeface="Courier" pitchFamily="34" charset="0"/>
                 <a:ea typeface="Courier" pitchFamily="34" charset="-122"/>
@@ -6972,7 +6972,7 @@
             <a:r>
               <a:rPr lang="en-US" sz="1000" dirty="0">
                 <a:solidFill>
-                  <a:srgbClr val="F8FAFC"/>
+                  <a:srgbClr val="0F172A"/>
                 </a:solidFill>
                 <a:latin typeface="Courier" pitchFamily="34" charset="0"/>
                 <a:ea typeface="Courier" pitchFamily="34" charset="-122"/>
@@ -7001,7 +7001,7 @@
             <a:r>
               <a:rPr lang="en-US" sz="1000" dirty="0">
                 <a:solidFill>
-                  <a:srgbClr val="F8FAFC"/>
+                  <a:srgbClr val="0F172A"/>
                 </a:solidFill>
                 <a:latin typeface="Courier" pitchFamily="34" charset="0"/>
                 <a:ea typeface="Courier" pitchFamily="34" charset="-122"/>
@@ -7021,7 +7021,7 @@
             <a:r>
               <a:rPr lang="en-US" sz="1000" dirty="0">
                 <a:solidFill>
-                  <a:srgbClr val="F8FAFC"/>
+                  <a:srgbClr val="0F172A"/>
                 </a:solidFill>
                 <a:latin typeface="Courier" pitchFamily="34" charset="0"/>
                 <a:ea typeface="Courier" pitchFamily="34" charset="-122"/>
@@ -7041,7 +7041,7 @@
             <a:r>
               <a:rPr lang="en-US" sz="1000" dirty="0">
                 <a:solidFill>
-                  <a:srgbClr val="F8FAFC"/>
+                  <a:srgbClr val="0F172A"/>
                 </a:solidFill>
                 <a:latin typeface="Courier" pitchFamily="34" charset="0"/>
                 <a:ea typeface="Courier" pitchFamily="34" charset="-122"/>
@@ -7067,7 +7067,7 @@
     <p:bg>
       <p:bgPr>
         <a:solidFill>
-          <a:srgbClr val="0B0F19"/>
+          <a:srgbClr val="F8FAFC"/>
         </a:solidFill>
       </p:bgPr>
     </p:bg>
@@ -7102,7 +7102,7 @@
           <a:noFill/>
           <a:ln w="12700">
             <a:solidFill>
-              <a:srgbClr val="2A3B5C"/>
+              <a:srgbClr val="E2E8F0"/>
             </a:solidFill>
             <a:prstDash val="solid"/>
           </a:ln>
@@ -7252,7 +7252,7 @@
             <a:r>
               <a:rPr lang="en-US" sz="1800" b="1" dirty="0">
                 <a:solidFill>
-                  <a:srgbClr val="F8FAFC"/>
+                  <a:srgbClr val="0F172A"/>
                 </a:solidFill>
                 <a:latin typeface="Arial" pitchFamily="34" charset="0"/>
                 <a:ea typeface="Arial" pitchFamily="34" charset="-122"/>
@@ -7281,7 +7281,7 @@
           <a:noFill/>
           <a:ln w="12700">
             <a:solidFill>
-              <a:srgbClr val="2A3B5C"/>
+              <a:srgbClr val="E2E8F0"/>
             </a:solidFill>
             <a:prstDash val="solid"/>
           </a:ln>
@@ -7380,11 +7380,11 @@
             <a:avLst/>
           </a:prstGeom>
           <a:solidFill>
-            <a:srgbClr val="131B2B"/>
+            <a:srgbClr val="FFFFFF"/>
           </a:solidFill>
           <a:ln w="12700">
             <a:solidFill>
-              <a:srgbClr val="2A3B5C"/>
+              <a:srgbClr val="E2E8F0"/>
             </a:solidFill>
             <a:prstDash val="solid"/>
           </a:ln>
@@ -7420,7 +7420,7 @@
             <a:r>
               <a:rPr lang="en-US" sz="1000" dirty="0">
                 <a:solidFill>
-                  <a:srgbClr val="F8FAFC"/>
+                  <a:srgbClr val="0F172A"/>
                 </a:solidFill>
                 <a:latin typeface="Courier" pitchFamily="34" charset="0"/>
                 <a:ea typeface="Courier" pitchFamily="34" charset="-122"/>
@@ -7440,7 +7440,7 @@
             <a:r>
               <a:rPr lang="en-US" sz="1000" dirty="0">
                 <a:solidFill>
-                  <a:srgbClr val="F8FAFC"/>
+                  <a:srgbClr val="0F172A"/>
                 </a:solidFill>
                 <a:latin typeface="Courier" pitchFamily="34" charset="0"/>
                 <a:ea typeface="Courier" pitchFamily="34" charset="-122"/>
@@ -7469,7 +7469,7 @@
             <a:r>
               <a:rPr lang="en-US" sz="1000" dirty="0">
                 <a:solidFill>
-                  <a:srgbClr val="F8FAFC"/>
+                  <a:srgbClr val="0F172A"/>
                 </a:solidFill>
                 <a:latin typeface="Courier" pitchFamily="34" charset="0"/>
                 <a:ea typeface="Courier" pitchFamily="34" charset="-122"/>
@@ -7489,7 +7489,7 @@
             <a:r>
               <a:rPr lang="en-US" sz="1000" dirty="0">
                 <a:solidFill>
-                  <a:srgbClr val="F8FAFC"/>
+                  <a:srgbClr val="0F172A"/>
                 </a:solidFill>
                 <a:latin typeface="Courier" pitchFamily="34" charset="0"/>
                 <a:ea typeface="Courier" pitchFamily="34" charset="-122"/>
@@ -7518,7 +7518,7 @@
             <a:r>
               <a:rPr lang="en-US" sz="1000" dirty="0">
                 <a:solidFill>
-                  <a:srgbClr val="F8FAFC"/>
+                  <a:srgbClr val="0F172A"/>
                 </a:solidFill>
                 <a:latin typeface="Courier" pitchFamily="34" charset="0"/>
                 <a:ea typeface="Courier" pitchFamily="34" charset="-122"/>
@@ -7538,7 +7538,7 @@
             <a:r>
               <a:rPr lang="en-US" sz="1000" dirty="0">
                 <a:solidFill>
-                  <a:srgbClr val="F8FAFC"/>
+                  <a:srgbClr val="0F172A"/>
                 </a:solidFill>
                 <a:latin typeface="Courier" pitchFamily="34" charset="0"/>
                 <a:ea typeface="Courier" pitchFamily="34" charset="-122"/>
@@ -7558,7 +7558,7 @@
             <a:r>
               <a:rPr lang="en-US" sz="1000" dirty="0">
                 <a:solidFill>
-                  <a:srgbClr val="F8FAFC"/>
+                  <a:srgbClr val="0F172A"/>
                 </a:solidFill>
                 <a:latin typeface="Courier" pitchFamily="34" charset="0"/>
                 <a:ea typeface="Courier" pitchFamily="34" charset="-122"/>
@@ -7584,7 +7584,7 @@
     <p:bg>
       <p:bgPr>
         <a:solidFill>
-          <a:srgbClr val="0B0F19"/>
+          <a:srgbClr val="F8FAFC"/>
         </a:solidFill>
       </p:bgPr>
     </p:bg>
@@ -7619,7 +7619,7 @@
           <a:noFill/>
           <a:ln w="12700">
             <a:solidFill>
-              <a:srgbClr val="2A3B5C"/>
+              <a:srgbClr val="E2E8F0"/>
             </a:solidFill>
             <a:prstDash val="solid"/>
           </a:ln>
@@ -7769,7 +7769,7 @@
             <a:r>
               <a:rPr lang="en-US" sz="1800" b="1" dirty="0">
                 <a:solidFill>
-                  <a:srgbClr val="F8FAFC"/>
+                  <a:srgbClr val="0F172A"/>
                 </a:solidFill>
                 <a:latin typeface="Arial" pitchFamily="34" charset="0"/>
                 <a:ea typeface="Arial" pitchFamily="34" charset="-122"/>
@@ -7798,7 +7798,7 @@
           <a:noFill/>
           <a:ln w="12700">
             <a:solidFill>
-              <a:srgbClr val="2A3B5C"/>
+              <a:srgbClr val="E2E8F0"/>
             </a:solidFill>
             <a:prstDash val="solid"/>
           </a:ln>
@@ -7897,11 +7897,11 @@
             <a:avLst/>
           </a:prstGeom>
           <a:solidFill>
-            <a:srgbClr val="131B2B"/>
+            <a:srgbClr val="FFFFFF"/>
           </a:solidFill>
           <a:ln w="12700">
             <a:solidFill>
-              <a:srgbClr val="2A3B5C"/>
+              <a:srgbClr val="E2E8F0"/>
             </a:solidFill>
             <a:prstDash val="solid"/>
           </a:ln>
@@ -7937,7 +7937,7 @@
             <a:r>
               <a:rPr lang="en-US" sz="1000" dirty="0">
                 <a:solidFill>
-                  <a:srgbClr val="F8FAFC"/>
+                  <a:srgbClr val="0F172A"/>
                 </a:solidFill>
                 <a:latin typeface="Courier" pitchFamily="34" charset="0"/>
                 <a:ea typeface="Courier" pitchFamily="34" charset="-122"/>
@@ -7957,7 +7957,7 @@
             <a:r>
               <a:rPr lang="en-US" sz="1000" dirty="0">
                 <a:solidFill>
-                  <a:srgbClr val="F8FAFC"/>
+                  <a:srgbClr val="0F172A"/>
                 </a:solidFill>
                 <a:latin typeface="Courier" pitchFamily="34" charset="0"/>
                 <a:ea typeface="Courier" pitchFamily="34" charset="-122"/>
@@ -7977,7 +7977,7 @@
             <a:r>
               <a:rPr lang="en-US" sz="1000" dirty="0">
                 <a:solidFill>
-                  <a:srgbClr val="F8FAFC"/>
+                  <a:srgbClr val="0F172A"/>
                 </a:solidFill>
                 <a:latin typeface="Courier" pitchFamily="34" charset="0"/>
                 <a:ea typeface="Courier" pitchFamily="34" charset="-122"/>
@@ -7997,7 +7997,7 @@
             <a:r>
               <a:rPr lang="en-US" sz="1000" dirty="0">
                 <a:solidFill>
-                  <a:srgbClr val="F8FAFC"/>
+                  <a:srgbClr val="0F172A"/>
                 </a:solidFill>
                 <a:latin typeface="Courier" pitchFamily="34" charset="0"/>
                 <a:ea typeface="Courier" pitchFamily="34" charset="-122"/>
@@ -8017,7 +8017,7 @@
             <a:r>
               <a:rPr lang="en-US" sz="1000" dirty="0">
                 <a:solidFill>
-                  <a:srgbClr val="F8FAFC"/>
+                  <a:srgbClr val="0F172A"/>
                 </a:solidFill>
                 <a:latin typeface="Courier" pitchFamily="34" charset="0"/>
                 <a:ea typeface="Courier" pitchFamily="34" charset="-122"/>
@@ -8037,7 +8037,7 @@
             <a:r>
               <a:rPr lang="en-US" sz="1000" dirty="0">
                 <a:solidFill>
-                  <a:srgbClr val="F8FAFC"/>
+                  <a:srgbClr val="0F172A"/>
                 </a:solidFill>
                 <a:latin typeface="Courier" pitchFamily="34" charset="0"/>
                 <a:ea typeface="Courier" pitchFamily="34" charset="-122"/>
@@ -8057,7 +8057,7 @@
             <a:r>
               <a:rPr lang="en-US" sz="1000" dirty="0">
                 <a:solidFill>
-                  <a:srgbClr val="F8FAFC"/>
+                  <a:srgbClr val="0F172A"/>
                 </a:solidFill>
                 <a:latin typeface="Courier" pitchFamily="34" charset="0"/>
                 <a:ea typeface="Courier" pitchFamily="34" charset="-122"/>
@@ -8077,7 +8077,7 @@
             <a:r>
               <a:rPr lang="en-US" sz="1000" dirty="0">
                 <a:solidFill>
-                  <a:srgbClr val="F8FAFC"/>
+                  <a:srgbClr val="0F172A"/>
                 </a:solidFill>
                 <a:latin typeface="Courier" pitchFamily="34" charset="0"/>
                 <a:ea typeface="Courier" pitchFamily="34" charset="-122"/>
@@ -8097,7 +8097,7 @@
             <a:r>
               <a:rPr lang="en-US" sz="1000" dirty="0">
                 <a:solidFill>
-                  <a:srgbClr val="F8FAFC"/>
+                  <a:srgbClr val="0F172A"/>
                 </a:solidFill>
                 <a:latin typeface="Courier" pitchFamily="34" charset="0"/>
                 <a:ea typeface="Courier" pitchFamily="34" charset="-122"/>
@@ -8117,7 +8117,7 @@
             <a:r>
               <a:rPr lang="en-US" sz="1000" dirty="0">
                 <a:solidFill>
-                  <a:srgbClr val="F8FAFC"/>
+                  <a:srgbClr val="0F172A"/>
                 </a:solidFill>
                 <a:latin typeface="Courier" pitchFamily="34" charset="0"/>
                 <a:ea typeface="Courier" pitchFamily="34" charset="-122"/>
@@ -8143,7 +8143,7 @@
     <p:bg>
       <p:bgPr>
         <a:solidFill>
-          <a:srgbClr val="0B0F19"/>
+          <a:srgbClr val="F8FAFC"/>
         </a:solidFill>
       </p:bgPr>
     </p:bg>
@@ -8178,7 +8178,7 @@
           <a:noFill/>
           <a:ln w="12700">
             <a:solidFill>
-              <a:srgbClr val="2A3B5C"/>
+              <a:srgbClr val="E2E8F0"/>
             </a:solidFill>
             <a:prstDash val="solid"/>
           </a:ln>
@@ -8328,7 +8328,7 @@
             <a:r>
               <a:rPr lang="en-US" sz="1800" b="1" dirty="0">
                 <a:solidFill>
-                  <a:srgbClr val="F8FAFC"/>
+                  <a:srgbClr val="0F172A"/>
                 </a:solidFill>
                 <a:latin typeface="Arial" pitchFamily="34" charset="0"/>
                 <a:ea typeface="Arial" pitchFamily="34" charset="-122"/>
@@ -8357,7 +8357,7 @@
           <a:noFill/>
           <a:ln w="12700">
             <a:solidFill>
-              <a:srgbClr val="2A3B5C"/>
+              <a:srgbClr val="E2E8F0"/>
             </a:solidFill>
             <a:prstDash val="solid"/>
           </a:ln>
@@ -8456,11 +8456,11 @@
             <a:avLst/>
           </a:prstGeom>
           <a:solidFill>
-            <a:srgbClr val="131B2B"/>
+            <a:srgbClr val="FFFFFF"/>
           </a:solidFill>
           <a:ln w="12700">
             <a:solidFill>
-              <a:srgbClr val="2A3B5C"/>
+              <a:srgbClr val="E2E8F0"/>
             </a:solidFill>
             <a:prstDash val="solid"/>
           </a:ln>
@@ -8496,7 +8496,7 @@
             <a:r>
               <a:rPr lang="en-US" sz="1000" dirty="0">
                 <a:solidFill>
-                  <a:srgbClr val="F8FAFC"/>
+                  <a:srgbClr val="0F172A"/>
                 </a:solidFill>
                 <a:latin typeface="Courier" pitchFamily="34" charset="0"/>
                 <a:ea typeface="Courier" pitchFamily="34" charset="-122"/>
@@ -8525,7 +8525,7 @@
             <a:r>
               <a:rPr lang="en-US" sz="1000" dirty="0">
                 <a:solidFill>
-                  <a:srgbClr val="F8FAFC"/>
+                  <a:srgbClr val="0F172A"/>
                 </a:solidFill>
                 <a:latin typeface="Courier" pitchFamily="34" charset="0"/>
                 <a:ea typeface="Courier" pitchFamily="34" charset="-122"/>
@@ -8554,7 +8554,7 @@
             <a:r>
               <a:rPr lang="en-US" sz="1000" dirty="0">
                 <a:solidFill>
-                  <a:srgbClr val="F8FAFC"/>
+                  <a:srgbClr val="0F172A"/>
                 </a:solidFill>
                 <a:latin typeface="Courier" pitchFamily="34" charset="0"/>
                 <a:ea typeface="Courier" pitchFamily="34" charset="-122"/>
@@ -8580,7 +8580,7 @@
     <p:bg>
       <p:bgPr>
         <a:solidFill>
-          <a:srgbClr val="0B0F19"/>
+          <a:srgbClr val="F8FAFC"/>
         </a:solidFill>
       </p:bgPr>
     </p:bg>
@@ -8615,7 +8615,7 @@
           <a:noFill/>
           <a:ln w="12700">
             <a:solidFill>
-              <a:srgbClr val="2A3B5C"/>
+              <a:srgbClr val="E2E8F0"/>
             </a:solidFill>
             <a:prstDash val="solid"/>
           </a:ln>
@@ -8765,7 +8765,7 @@
             <a:r>
               <a:rPr lang="en-US" sz="1800" b="1" dirty="0">
                 <a:solidFill>
-                  <a:srgbClr val="F8FAFC"/>
+                  <a:srgbClr val="0F172A"/>
                 </a:solidFill>
                 <a:latin typeface="Arial" pitchFamily="34" charset="0"/>
                 <a:ea typeface="Arial" pitchFamily="34" charset="-122"/>
@@ -8794,7 +8794,7 @@
           <a:noFill/>
           <a:ln w="12700">
             <a:solidFill>
-              <a:srgbClr val="2A3B5C"/>
+              <a:srgbClr val="E2E8F0"/>
             </a:solidFill>
             <a:prstDash val="solid"/>
           </a:ln>
@@ -8893,11 +8893,11 @@
             <a:avLst/>
           </a:prstGeom>
           <a:solidFill>
-            <a:srgbClr val="131B2B"/>
+            <a:srgbClr val="FFFFFF"/>
           </a:solidFill>
           <a:ln w="12700">
             <a:solidFill>
-              <a:srgbClr val="2A3B5C"/>
+              <a:srgbClr val="E2E8F0"/>
             </a:solidFill>
             <a:prstDash val="solid"/>
           </a:ln>
@@ -8933,7 +8933,7 @@
             <a:r>
               <a:rPr lang="en-US" sz="1000" dirty="0">
                 <a:solidFill>
-                  <a:srgbClr val="F8FAFC"/>
+                  <a:srgbClr val="0F172A"/>
                 </a:solidFill>
                 <a:latin typeface="Courier" pitchFamily="34" charset="0"/>
                 <a:ea typeface="Courier" pitchFamily="34" charset="-122"/>
@@ -8953,7 +8953,7 @@
             <a:r>
               <a:rPr lang="en-US" sz="1000" dirty="0">
                 <a:solidFill>
-                  <a:srgbClr val="F8FAFC"/>
+                  <a:srgbClr val="0F172A"/>
                 </a:solidFill>
                 <a:latin typeface="Courier" pitchFamily="34" charset="0"/>
                 <a:ea typeface="Courier" pitchFamily="34" charset="-122"/>
@@ -8982,7 +8982,7 @@
             <a:r>
               <a:rPr lang="en-US" sz="1000" dirty="0">
                 <a:solidFill>
-                  <a:srgbClr val="F8FAFC"/>
+                  <a:srgbClr val="0F172A"/>
                 </a:solidFill>
                 <a:latin typeface="Courier" pitchFamily="34" charset="0"/>
                 <a:ea typeface="Courier" pitchFamily="34" charset="-122"/>
@@ -9002,7 +9002,7 @@
             <a:r>
               <a:rPr lang="en-US" sz="1000" dirty="0">
                 <a:solidFill>
-                  <a:srgbClr val="F8FAFC"/>
+                  <a:srgbClr val="0F172A"/>
                 </a:solidFill>
                 <a:latin typeface="Courier" pitchFamily="34" charset="0"/>
                 <a:ea typeface="Courier" pitchFamily="34" charset="-122"/>
@@ -9022,7 +9022,7 @@
             <a:r>
               <a:rPr lang="en-US" sz="1000" dirty="0">
                 <a:solidFill>
-                  <a:srgbClr val="F8FAFC"/>
+                  <a:srgbClr val="0F172A"/>
                 </a:solidFill>
                 <a:latin typeface="Courier" pitchFamily="34" charset="0"/>
                 <a:ea typeface="Courier" pitchFamily="34" charset="-122"/>
@@ -9042,7 +9042,7 @@
             <a:r>
               <a:rPr lang="en-US" sz="1000" dirty="0">
                 <a:solidFill>
-                  <a:srgbClr val="F8FAFC"/>
+                  <a:srgbClr val="0F172A"/>
                 </a:solidFill>
                 <a:latin typeface="Courier" pitchFamily="34" charset="0"/>
                 <a:ea typeface="Courier" pitchFamily="34" charset="-122"/>
@@ -9062,7 +9062,7 @@
             <a:r>
               <a:rPr lang="en-US" sz="1000" dirty="0">
                 <a:solidFill>
-                  <a:srgbClr val="F8FAFC"/>
+                  <a:srgbClr val="0F172A"/>
                 </a:solidFill>
                 <a:latin typeface="Courier" pitchFamily="34" charset="0"/>
                 <a:ea typeface="Courier" pitchFamily="34" charset="-122"/>
@@ -9091,7 +9091,7 @@
             <a:r>
               <a:rPr lang="en-US" sz="1000" dirty="0">
                 <a:solidFill>
-                  <a:srgbClr val="F8FAFC"/>
+                  <a:srgbClr val="0F172A"/>
                 </a:solidFill>
                 <a:latin typeface="Courier" pitchFamily="34" charset="0"/>
                 <a:ea typeface="Courier" pitchFamily="34" charset="-122"/>
@@ -9117,7 +9117,7 @@
     <p:bg>
       <p:bgPr>
         <a:solidFill>
-          <a:srgbClr val="0B0F19"/>
+          <a:srgbClr val="F8FAFC"/>
         </a:solidFill>
       </p:bgPr>
     </p:bg>
@@ -9152,7 +9152,7 @@
           <a:noFill/>
           <a:ln w="12700">
             <a:solidFill>
-              <a:srgbClr val="2A3B5C"/>
+              <a:srgbClr val="E2E8F0"/>
             </a:solidFill>
             <a:prstDash val="solid"/>
           </a:ln>
@@ -9302,7 +9302,7 @@
             <a:r>
               <a:rPr lang="en-US" sz="1800" b="1" dirty="0">
                 <a:solidFill>
-                  <a:srgbClr val="F8FAFC"/>
+                  <a:srgbClr val="0F172A"/>
                 </a:solidFill>
                 <a:latin typeface="Arial" pitchFamily="34" charset="0"/>
                 <a:ea typeface="Arial" pitchFamily="34" charset="-122"/>
@@ -9331,7 +9331,7 @@
           <a:noFill/>
           <a:ln w="12700">
             <a:solidFill>
-              <a:srgbClr val="2A3B5C"/>
+              <a:srgbClr val="E2E8F0"/>
             </a:solidFill>
             <a:prstDash val="solid"/>
           </a:ln>
@@ -9430,11 +9430,11 @@
             <a:avLst/>
           </a:prstGeom>
           <a:solidFill>
-            <a:srgbClr val="131B2B"/>
+            <a:srgbClr val="FFFFFF"/>
           </a:solidFill>
           <a:ln w="12700">
             <a:solidFill>
-              <a:srgbClr val="2A3B5C"/>
+              <a:srgbClr val="E2E8F0"/>
             </a:solidFill>
             <a:prstDash val="solid"/>
           </a:ln>
@@ -9470,7 +9470,7 @@
             <a:r>
               <a:rPr lang="en-US" sz="1000" dirty="0">
                 <a:solidFill>
-                  <a:srgbClr val="F8FAFC"/>
+                  <a:srgbClr val="0F172A"/>
                 </a:solidFill>
                 <a:latin typeface="Courier" pitchFamily="34" charset="0"/>
                 <a:ea typeface="Courier" pitchFamily="34" charset="-122"/>
@@ -9490,7 +9490,7 @@
             <a:r>
               <a:rPr lang="en-US" sz="1000" dirty="0">
                 <a:solidFill>
-                  <a:srgbClr val="F8FAFC"/>
+                  <a:srgbClr val="0F172A"/>
                 </a:solidFill>
                 <a:latin typeface="Courier" pitchFamily="34" charset="0"/>
                 <a:ea typeface="Courier" pitchFamily="34" charset="-122"/>
@@ -9510,7 +9510,7 @@
             <a:r>
               <a:rPr lang="en-US" sz="1000" dirty="0">
                 <a:solidFill>
-                  <a:srgbClr val="F8FAFC"/>
+                  <a:srgbClr val="0F172A"/>
                 </a:solidFill>
                 <a:latin typeface="Courier" pitchFamily="34" charset="0"/>
                 <a:ea typeface="Courier" pitchFamily="34" charset="-122"/>
@@ -9539,7 +9539,7 @@
             <a:r>
               <a:rPr lang="en-US" sz="1000" dirty="0">
                 <a:solidFill>
-                  <a:srgbClr val="F8FAFC"/>
+                  <a:srgbClr val="0F172A"/>
                 </a:solidFill>
                 <a:latin typeface="Courier" pitchFamily="34" charset="0"/>
                 <a:ea typeface="Courier" pitchFamily="34" charset="-122"/>
@@ -9559,7 +9559,7 @@
             <a:r>
               <a:rPr lang="en-US" sz="1000" dirty="0">
                 <a:solidFill>
-                  <a:srgbClr val="F8FAFC"/>
+                  <a:srgbClr val="0F172A"/>
                 </a:solidFill>
                 <a:latin typeface="Courier" pitchFamily="34" charset="0"/>
                 <a:ea typeface="Courier" pitchFamily="34" charset="-122"/>
@@ -9579,7 +9579,7 @@
             <a:r>
               <a:rPr lang="en-US" sz="1000" dirty="0">
                 <a:solidFill>
-                  <a:srgbClr val="F8FAFC"/>
+                  <a:srgbClr val="0F172A"/>
                 </a:solidFill>
                 <a:latin typeface="Courier" pitchFamily="34" charset="0"/>
                 <a:ea typeface="Courier" pitchFamily="34" charset="-122"/>
@@ -9605,7 +9605,7 @@
     <p:bg>
       <p:bgPr>
         <a:solidFill>
-          <a:srgbClr val="0B0F19"/>
+          <a:srgbClr val="F8FAFC"/>
         </a:solidFill>
       </p:bgPr>
     </p:bg>
@@ -9640,7 +9640,7 @@
           <a:noFill/>
           <a:ln w="12700">
             <a:solidFill>
-              <a:srgbClr val="2A3B5C"/>
+              <a:srgbClr val="E2E8F0"/>
             </a:solidFill>
             <a:prstDash val="solid"/>
           </a:ln>
@@ -9790,7 +9790,7 @@
             <a:r>
               <a:rPr lang="en-US" sz="1800" b="1" dirty="0">
                 <a:solidFill>
-                  <a:srgbClr val="F8FAFC"/>
+                  <a:srgbClr val="0F172A"/>
                 </a:solidFill>
                 <a:latin typeface="Arial" pitchFamily="34" charset="0"/>
                 <a:ea typeface="Arial" pitchFamily="34" charset="-122"/>
@@ -9819,7 +9819,7 @@
           <a:noFill/>
           <a:ln w="12700">
             <a:solidFill>
-              <a:srgbClr val="2A3B5C"/>
+              <a:srgbClr val="E2E8F0"/>
             </a:solidFill>
             <a:prstDash val="solid"/>
           </a:ln>
@@ -9918,11 +9918,11 @@
             <a:avLst/>
           </a:prstGeom>
           <a:solidFill>
-            <a:srgbClr val="131B2B"/>
+            <a:srgbClr val="FFFFFF"/>
           </a:solidFill>
           <a:ln w="12700">
             <a:solidFill>
-              <a:srgbClr val="2A3B5C"/>
+              <a:srgbClr val="E2E8F0"/>
             </a:solidFill>
             <a:prstDash val="solid"/>
           </a:ln>
@@ -9958,7 +9958,7 @@
             <a:r>
               <a:rPr lang="en-US" sz="1000" dirty="0">
                 <a:solidFill>
-                  <a:srgbClr val="F8FAFC"/>
+                  <a:srgbClr val="0F172A"/>
                 </a:solidFill>
                 <a:latin typeface="Courier" pitchFamily="34" charset="0"/>
                 <a:ea typeface="Courier" pitchFamily="34" charset="-122"/>
@@ -9978,7 +9978,7 @@
             <a:r>
               <a:rPr lang="en-US" sz="1000" dirty="0">
                 <a:solidFill>
-                  <a:srgbClr val="F8FAFC"/>
+                  <a:srgbClr val="0F172A"/>
                 </a:solidFill>
                 <a:latin typeface="Courier" pitchFamily="34" charset="0"/>
                 <a:ea typeface="Courier" pitchFamily="34" charset="-122"/>
@@ -9998,7 +9998,7 @@
             <a:r>
               <a:rPr lang="en-US" sz="1000" dirty="0">
                 <a:solidFill>
-                  <a:srgbClr val="F8FAFC"/>
+                  <a:srgbClr val="0F172A"/>
                 </a:solidFill>
                 <a:latin typeface="Courier" pitchFamily="34" charset="0"/>
                 <a:ea typeface="Courier" pitchFamily="34" charset="-122"/>
@@ -10027,7 +10027,7 @@
             <a:r>
               <a:rPr lang="en-US" sz="1000" dirty="0">
                 <a:solidFill>
-                  <a:srgbClr val="F8FAFC"/>
+                  <a:srgbClr val="0F172A"/>
                 </a:solidFill>
                 <a:latin typeface="Courier" pitchFamily="34" charset="0"/>
                 <a:ea typeface="Courier" pitchFamily="34" charset="-122"/>
@@ -10047,7 +10047,7 @@
             <a:r>
               <a:rPr lang="en-US" sz="1000" dirty="0">
                 <a:solidFill>
-                  <a:srgbClr val="F8FAFC"/>
+                  <a:srgbClr val="0F172A"/>
                 </a:solidFill>
                 <a:latin typeface="Courier" pitchFamily="34" charset="0"/>
                 <a:ea typeface="Courier" pitchFamily="34" charset="-122"/>
@@ -10076,7 +10076,7 @@
             <a:r>
               <a:rPr lang="en-US" sz="1000" dirty="0">
                 <a:solidFill>
-                  <a:srgbClr val="F8FAFC"/>
+                  <a:srgbClr val="0F172A"/>
                 </a:solidFill>
                 <a:latin typeface="Courier" pitchFamily="34" charset="0"/>
                 <a:ea typeface="Courier" pitchFamily="34" charset="-122"/>
@@ -10096,7 +10096,7 @@
             <a:r>
               <a:rPr lang="en-US" sz="1000" dirty="0">
                 <a:solidFill>
-                  <a:srgbClr val="F8FAFC"/>
+                  <a:srgbClr val="0F172A"/>
                 </a:solidFill>
                 <a:latin typeface="Courier" pitchFamily="34" charset="0"/>
                 <a:ea typeface="Courier" pitchFamily="34" charset="-122"/>
@@ -10122,7 +10122,7 @@
     <p:bg>
       <p:bgPr>
         <a:solidFill>
-          <a:srgbClr val="0B0F19"/>
+          <a:srgbClr val="F8FAFC"/>
         </a:solidFill>
       </p:bgPr>
     </p:bg>
@@ -10157,7 +10157,7 @@
           <a:noFill/>
           <a:ln w="12700">
             <a:solidFill>
-              <a:srgbClr val="2A3B5C"/>
+              <a:srgbClr val="E2E8F0"/>
             </a:solidFill>
             <a:prstDash val="solid"/>
           </a:ln>
@@ -10307,7 +10307,7 @@
             <a:r>
               <a:rPr lang="en-US" sz="1800" b="1" dirty="0">
                 <a:solidFill>
-                  <a:srgbClr val="F8FAFC"/>
+                  <a:srgbClr val="0F172A"/>
                 </a:solidFill>
                 <a:latin typeface="Arial" pitchFamily="34" charset="0"/>
                 <a:ea typeface="Arial" pitchFamily="34" charset="-122"/>
@@ -10336,7 +10336,7 @@
           <a:noFill/>
           <a:ln w="12700">
             <a:solidFill>
-              <a:srgbClr val="2A3B5C"/>
+              <a:srgbClr val="E2E8F0"/>
             </a:solidFill>
             <a:prstDash val="solid"/>
           </a:ln>
@@ -10435,11 +10435,11 @@
             <a:avLst/>
           </a:prstGeom>
           <a:solidFill>
-            <a:srgbClr val="131B2B"/>
+            <a:srgbClr val="FFFFFF"/>
           </a:solidFill>
           <a:ln w="12700">
             <a:solidFill>
-              <a:srgbClr val="2A3B5C"/>
+              <a:srgbClr val="E2E8F0"/>
             </a:solidFill>
             <a:prstDash val="solid"/>
           </a:ln>
@@ -10475,7 +10475,7 @@
             <a:r>
               <a:rPr lang="en-US" sz="1000" dirty="0">
                 <a:solidFill>
-                  <a:srgbClr val="F8FAFC"/>
+                  <a:srgbClr val="0F172A"/>
                 </a:solidFill>
                 <a:latin typeface="Courier" pitchFamily="34" charset="0"/>
                 <a:ea typeface="Courier" pitchFamily="34" charset="-122"/>
@@ -10495,7 +10495,7 @@
             <a:r>
               <a:rPr lang="en-US" sz="1000" dirty="0">
                 <a:solidFill>
-                  <a:srgbClr val="F8FAFC"/>
+                  <a:srgbClr val="0F172A"/>
                 </a:solidFill>
                 <a:latin typeface="Courier" pitchFamily="34" charset="0"/>
                 <a:ea typeface="Courier" pitchFamily="34" charset="-122"/>
@@ -10524,7 +10524,7 @@
             <a:r>
               <a:rPr lang="en-US" sz="1000" dirty="0">
                 <a:solidFill>
-                  <a:srgbClr val="F8FAFC"/>
+                  <a:srgbClr val="0F172A"/>
                 </a:solidFill>
                 <a:latin typeface="Courier" pitchFamily="34" charset="0"/>
                 <a:ea typeface="Courier" pitchFamily="34" charset="-122"/>
@@ -10544,7 +10544,7 @@
             <a:r>
               <a:rPr lang="en-US" sz="1000" dirty="0">
                 <a:solidFill>
-                  <a:srgbClr val="F8FAFC"/>
+                  <a:srgbClr val="0F172A"/>
                 </a:solidFill>
                 <a:latin typeface="Courier" pitchFamily="34" charset="0"/>
                 <a:ea typeface="Courier" pitchFamily="34" charset="-122"/>
@@ -10564,7 +10564,7 @@
             <a:r>
               <a:rPr lang="en-US" sz="1000" dirty="0">
                 <a:solidFill>
-                  <a:srgbClr val="F8FAFC"/>
+                  <a:srgbClr val="0F172A"/>
                 </a:solidFill>
                 <a:latin typeface="Courier" pitchFamily="34" charset="0"/>
                 <a:ea typeface="Courier" pitchFamily="34" charset="-122"/>
@@ -10584,7 +10584,7 @@
             <a:r>
               <a:rPr lang="en-US" sz="1000" dirty="0">
                 <a:solidFill>
-                  <a:srgbClr val="F8FAFC"/>
+                  <a:srgbClr val="0F172A"/>
                 </a:solidFill>
                 <a:latin typeface="Courier" pitchFamily="34" charset="0"/>
                 <a:ea typeface="Courier" pitchFamily="34" charset="-122"/>
@@ -10610,7 +10610,7 @@
     <p:bg>
       <p:bgPr>
         <a:solidFill>
-          <a:srgbClr val="0B0F19"/>
+          <a:srgbClr val="F8FAFC"/>
         </a:solidFill>
       </p:bgPr>
     </p:bg>
@@ -10645,7 +10645,7 @@
           <a:noFill/>
           <a:ln w="12700">
             <a:solidFill>
-              <a:srgbClr val="2A3B5C"/>
+              <a:srgbClr val="E2E8F0"/>
             </a:solidFill>
             <a:prstDash val="solid"/>
           </a:ln>
@@ -10795,7 +10795,7 @@
             <a:r>
               <a:rPr lang="en-US" sz="1800" b="1" dirty="0">
                 <a:solidFill>
-                  <a:srgbClr val="F8FAFC"/>
+                  <a:srgbClr val="0F172A"/>
                 </a:solidFill>
                 <a:latin typeface="Arial" pitchFamily="34" charset="0"/>
                 <a:ea typeface="Arial" pitchFamily="34" charset="-122"/>
@@ -10824,7 +10824,7 @@
           <a:noFill/>
           <a:ln w="12700">
             <a:solidFill>
-              <a:srgbClr val="2A3B5C"/>
+              <a:srgbClr val="E2E8F0"/>
             </a:solidFill>
             <a:prstDash val="solid"/>
           </a:ln>
@@ -10923,11 +10923,11 @@
             <a:avLst/>
           </a:prstGeom>
           <a:solidFill>
-            <a:srgbClr val="131B2B"/>
+            <a:srgbClr val="FFFFFF"/>
           </a:solidFill>
           <a:ln w="12700">
             <a:solidFill>
-              <a:srgbClr val="2A3B5C"/>
+              <a:srgbClr val="E2E8F0"/>
             </a:solidFill>
             <a:prstDash val="solid"/>
           </a:ln>
@@ -10963,7 +10963,7 @@
             <a:r>
               <a:rPr lang="en-US" sz="1000" dirty="0">
                 <a:solidFill>
-                  <a:srgbClr val="F8FAFC"/>
+                  <a:srgbClr val="0F172A"/>
                 </a:solidFill>
                 <a:latin typeface="Courier" pitchFamily="34" charset="0"/>
                 <a:ea typeface="Courier" pitchFamily="34" charset="-122"/>
@@ -10983,7 +10983,7 @@
             <a:r>
               <a:rPr lang="en-US" sz="1000" dirty="0">
                 <a:solidFill>
-                  <a:srgbClr val="F8FAFC"/>
+                  <a:srgbClr val="0F172A"/>
                 </a:solidFill>
                 <a:latin typeface="Courier" pitchFamily="34" charset="0"/>
                 <a:ea typeface="Courier" pitchFamily="34" charset="-122"/>
@@ -11003,7 +11003,7 @@
             <a:r>
               <a:rPr lang="en-US" sz="1000" dirty="0">
                 <a:solidFill>
-                  <a:srgbClr val="F8FAFC"/>
+                  <a:srgbClr val="0F172A"/>
                 </a:solidFill>
                 <a:latin typeface="Courier" pitchFamily="34" charset="0"/>
                 <a:ea typeface="Courier" pitchFamily="34" charset="-122"/>
@@ -11029,7 +11029,7 @@
     <p:bg>
       <p:bgPr>
         <a:solidFill>
-          <a:srgbClr val="0B0F19"/>
+          <a:srgbClr val="F8FAFC"/>
         </a:solidFill>
       </p:bgPr>
     </p:bg>
@@ -11064,7 +11064,7 @@
           <a:noFill/>
           <a:ln w="12700">
             <a:solidFill>
-              <a:srgbClr val="2A3B5C"/>
+              <a:srgbClr val="E2E8F0"/>
             </a:solidFill>
             <a:prstDash val="solid"/>
           </a:ln>
@@ -11214,7 +11214,7 @@
             <a:r>
               <a:rPr lang="en-US" sz="1800" b="1" dirty="0">
                 <a:solidFill>
-                  <a:srgbClr val="F8FAFC"/>
+                  <a:srgbClr val="0F172A"/>
                 </a:solidFill>
                 <a:latin typeface="Arial" pitchFamily="34" charset="0"/>
                 <a:ea typeface="Arial" pitchFamily="34" charset="-122"/>
@@ -11243,7 +11243,7 @@
           <a:noFill/>
           <a:ln w="12700">
             <a:solidFill>
-              <a:srgbClr val="2A3B5C"/>
+              <a:srgbClr val="E2E8F0"/>
             </a:solidFill>
             <a:prstDash val="solid"/>
           </a:ln>
@@ -11342,11 +11342,11 @@
             <a:avLst/>
           </a:prstGeom>
           <a:solidFill>
-            <a:srgbClr val="131B2B"/>
+            <a:srgbClr val="FFFFFF"/>
           </a:solidFill>
           <a:ln w="12700">
             <a:solidFill>
-              <a:srgbClr val="2A3B5C"/>
+              <a:srgbClr val="E2E8F0"/>
             </a:solidFill>
             <a:prstDash val="solid"/>
           </a:ln>
@@ -11382,7 +11382,7 @@
             <a:r>
               <a:rPr lang="en-US" sz="1000" dirty="0">
                 <a:solidFill>
-                  <a:srgbClr val="F8FAFC"/>
+                  <a:srgbClr val="0F172A"/>
                 </a:solidFill>
                 <a:latin typeface="Courier" pitchFamily="34" charset="0"/>
                 <a:ea typeface="Courier" pitchFamily="34" charset="-122"/>
@@ -11402,7 +11402,7 @@
             <a:r>
               <a:rPr lang="en-US" sz="1000" dirty="0">
                 <a:solidFill>
-                  <a:srgbClr val="F8FAFC"/>
+                  <a:srgbClr val="0F172A"/>
                 </a:solidFill>
                 <a:latin typeface="Courier" pitchFamily="34" charset="0"/>
                 <a:ea typeface="Courier" pitchFamily="34" charset="-122"/>
@@ -11422,7 +11422,7 @@
             <a:r>
               <a:rPr lang="en-US" sz="1000" dirty="0">
                 <a:solidFill>
-                  <a:srgbClr val="F8FAFC"/>
+                  <a:srgbClr val="0F172A"/>
                 </a:solidFill>
                 <a:latin typeface="Courier" pitchFamily="34" charset="0"/>
                 <a:ea typeface="Courier" pitchFamily="34" charset="-122"/>
@@ -11442,7 +11442,7 @@
             <a:r>
               <a:rPr lang="en-US" sz="1000" dirty="0">
                 <a:solidFill>
-                  <a:srgbClr val="F8FAFC"/>
+                  <a:srgbClr val="0F172A"/>
                 </a:solidFill>
                 <a:latin typeface="Courier" pitchFamily="34" charset="0"/>
                 <a:ea typeface="Courier" pitchFamily="34" charset="-122"/>
@@ -11462,7 +11462,7 @@
             <a:r>
               <a:rPr lang="en-US" sz="1000" dirty="0">
                 <a:solidFill>
-                  <a:srgbClr val="F8FAFC"/>
+                  <a:srgbClr val="0F172A"/>
                 </a:solidFill>
                 <a:latin typeface="Courier" pitchFamily="34" charset="0"/>
                 <a:ea typeface="Courier" pitchFamily="34" charset="-122"/>
@@ -11482,7 +11482,7 @@
             <a:r>
               <a:rPr lang="en-US" sz="1000" dirty="0">
                 <a:solidFill>
-                  <a:srgbClr val="F8FAFC"/>
+                  <a:srgbClr val="0F172A"/>
                 </a:solidFill>
                 <a:latin typeface="Courier" pitchFamily="34" charset="0"/>
                 <a:ea typeface="Courier" pitchFamily="34" charset="-122"/>
@@ -11502,7 +11502,7 @@
             <a:r>
               <a:rPr lang="en-US" sz="1000" dirty="0">
                 <a:solidFill>
-                  <a:srgbClr val="F8FAFC"/>
+                  <a:srgbClr val="0F172A"/>
                 </a:solidFill>
                 <a:latin typeface="Courier" pitchFamily="34" charset="0"/>
                 <a:ea typeface="Courier" pitchFamily="34" charset="-122"/>
@@ -11528,7 +11528,7 @@
     <p:bg>
       <p:bgPr>
         <a:solidFill>
-          <a:srgbClr val="0B0F19"/>
+          <a:srgbClr val="F8FAFC"/>
         </a:solidFill>
       </p:bgPr>
     </p:bg>
@@ -11563,7 +11563,7 @@
           <a:noFill/>
           <a:ln w="12700">
             <a:solidFill>
-              <a:srgbClr val="2A3B5C"/>
+              <a:srgbClr val="E2E8F0"/>
             </a:solidFill>
             <a:prstDash val="solid"/>
           </a:ln>
@@ -11713,7 +11713,7 @@
             <a:r>
               <a:rPr lang="en-US" sz="1800" b="1" dirty="0">
                 <a:solidFill>
-                  <a:srgbClr val="F8FAFC"/>
+                  <a:srgbClr val="0F172A"/>
                 </a:solidFill>
                 <a:latin typeface="Arial" pitchFamily="34" charset="0"/>
                 <a:ea typeface="Arial" pitchFamily="34" charset="-122"/>
@@ -11742,7 +11742,7 @@
           <a:noFill/>
           <a:ln w="12700">
             <a:solidFill>
-              <a:srgbClr val="2A3B5C"/>
+              <a:srgbClr val="E2E8F0"/>
             </a:solidFill>
             <a:prstDash val="solid"/>
           </a:ln>
@@ -11841,11 +11841,11 @@
             <a:avLst/>
           </a:prstGeom>
           <a:solidFill>
-            <a:srgbClr val="131B2B"/>
+            <a:srgbClr val="FFFFFF"/>
           </a:solidFill>
           <a:ln w="12700">
             <a:solidFill>
-              <a:srgbClr val="2A3B5C"/>
+              <a:srgbClr val="E2E8F0"/>
             </a:solidFill>
             <a:prstDash val="solid"/>
           </a:ln>
@@ -11881,7 +11881,7 @@
             <a:r>
               <a:rPr lang="en-US" sz="1000" dirty="0">
                 <a:solidFill>
-                  <a:srgbClr val="F8FAFC"/>
+                  <a:srgbClr val="0F172A"/>
                 </a:solidFill>
                 <a:latin typeface="Courier" pitchFamily="34" charset="0"/>
                 <a:ea typeface="Courier" pitchFamily="34" charset="-122"/>
@@ -11910,7 +11910,7 @@
             <a:r>
               <a:rPr lang="en-US" sz="1000" dirty="0">
                 <a:solidFill>
-                  <a:srgbClr val="F8FAFC"/>
+                  <a:srgbClr val="0F172A"/>
                 </a:solidFill>
                 <a:latin typeface="Courier" pitchFamily="34" charset="0"/>
                 <a:ea typeface="Courier" pitchFamily="34" charset="-122"/>
@@ -11939,7 +11939,7 @@
             <a:r>
               <a:rPr lang="en-US" sz="1000" dirty="0">
                 <a:solidFill>
-                  <a:srgbClr val="F8FAFC"/>
+                  <a:srgbClr val="0F172A"/>
                 </a:solidFill>
                 <a:latin typeface="Courier" pitchFamily="34" charset="0"/>
                 <a:ea typeface="Courier" pitchFamily="34" charset="-122"/>
@@ -11965,7 +11965,7 @@
     <p:bg>
       <p:bgPr>
         <a:solidFill>
-          <a:srgbClr val="0B0F19"/>
+          <a:srgbClr val="F8FAFC"/>
         </a:solidFill>
       </p:bgPr>
     </p:bg>
@@ -12000,7 +12000,7 @@
           <a:noFill/>
           <a:ln w="12700">
             <a:solidFill>
-              <a:srgbClr val="2A3B5C"/>
+              <a:srgbClr val="E2E8F0"/>
             </a:solidFill>
             <a:prstDash val="solid"/>
           </a:ln>
@@ -12150,7 +12150,7 @@
             <a:r>
               <a:rPr lang="en-US" sz="1800" b="1" dirty="0">
                 <a:solidFill>
-                  <a:srgbClr val="F8FAFC"/>
+                  <a:srgbClr val="0F172A"/>
                 </a:solidFill>
                 <a:latin typeface="Arial" pitchFamily="34" charset="0"/>
                 <a:ea typeface="Arial" pitchFamily="34" charset="-122"/>
@@ -12179,7 +12179,7 @@
           <a:noFill/>
           <a:ln w="12700">
             <a:solidFill>
-              <a:srgbClr val="2A3B5C"/>
+              <a:srgbClr val="E2E8F0"/>
             </a:solidFill>
             <a:prstDash val="solid"/>
           </a:ln>
@@ -12278,11 +12278,11 @@
             <a:avLst/>
           </a:prstGeom>
           <a:solidFill>
-            <a:srgbClr val="131B2B"/>
+            <a:srgbClr val="FFFFFF"/>
           </a:solidFill>
           <a:ln w="12700">
             <a:solidFill>
-              <a:srgbClr val="2A3B5C"/>
+              <a:srgbClr val="E2E8F0"/>
             </a:solidFill>
             <a:prstDash val="solid"/>
           </a:ln>
@@ -12318,7 +12318,7 @@
             <a:r>
               <a:rPr lang="en-US" sz="1000" dirty="0">
                 <a:solidFill>
-                  <a:srgbClr val="F8FAFC"/>
+                  <a:srgbClr val="0F172A"/>
                 </a:solidFill>
                 <a:latin typeface="Courier" pitchFamily="34" charset="0"/>
                 <a:ea typeface="Courier" pitchFamily="34" charset="-122"/>
@@ -12347,7 +12347,7 @@
             <a:r>
               <a:rPr lang="en-US" sz="1000" dirty="0">
                 <a:solidFill>
-                  <a:srgbClr val="F8FAFC"/>
+                  <a:srgbClr val="0F172A"/>
                 </a:solidFill>
                 <a:latin typeface="Courier" pitchFamily="34" charset="0"/>
                 <a:ea typeface="Courier" pitchFamily="34" charset="-122"/>
@@ -12376,7 +12376,7 @@
             <a:r>
               <a:rPr lang="en-US" sz="1000" dirty="0">
                 <a:solidFill>
-                  <a:srgbClr val="F8FAFC"/>
+                  <a:srgbClr val="0F172A"/>
                 </a:solidFill>
                 <a:latin typeface="Courier" pitchFamily="34" charset="0"/>
                 <a:ea typeface="Courier" pitchFamily="34" charset="-122"/>
@@ -12402,7 +12402,7 @@
     <p:bg>
       <p:bgPr>
         <a:solidFill>
-          <a:srgbClr val="0B0F19"/>
+          <a:srgbClr val="F8FAFC"/>
         </a:solidFill>
       </p:bgPr>
     </p:bg>
@@ -12437,7 +12437,7 @@
           <a:noFill/>
           <a:ln w="12700">
             <a:solidFill>
-              <a:srgbClr val="2A3B5C"/>
+              <a:srgbClr val="E2E8F0"/>
             </a:solidFill>
             <a:prstDash val="solid"/>
           </a:ln>
@@ -12587,7 +12587,7 @@
             <a:r>
               <a:rPr lang="en-US" sz="1800" b="1" dirty="0">
                 <a:solidFill>
-                  <a:srgbClr val="F8FAFC"/>
+                  <a:srgbClr val="0F172A"/>
                 </a:solidFill>
                 <a:latin typeface="Arial" pitchFamily="34" charset="0"/>
                 <a:ea typeface="Arial" pitchFamily="34" charset="-122"/>
@@ -12616,7 +12616,7 @@
           <a:noFill/>
           <a:ln w="12700">
             <a:solidFill>
-              <a:srgbClr val="2A3B5C"/>
+              <a:srgbClr val="E2E8F0"/>
             </a:solidFill>
             <a:prstDash val="solid"/>
           </a:ln>
@@ -12715,11 +12715,11 @@
             <a:avLst/>
           </a:prstGeom>
           <a:solidFill>
-            <a:srgbClr val="131B2B"/>
+            <a:srgbClr val="FFFFFF"/>
           </a:solidFill>
           <a:ln w="12700">
             <a:solidFill>
-              <a:srgbClr val="2A3B5C"/>
+              <a:srgbClr val="E2E8F0"/>
             </a:solidFill>
             <a:prstDash val="solid"/>
           </a:ln>
@@ -12755,7 +12755,7 @@
             <a:r>
               <a:rPr lang="en-US" sz="1000" dirty="0">
                 <a:solidFill>
-                  <a:srgbClr val="F8FAFC"/>
+                  <a:srgbClr val="0F172A"/>
                 </a:solidFill>
                 <a:latin typeface="Courier" pitchFamily="34" charset="0"/>
                 <a:ea typeface="Courier" pitchFamily="34" charset="-122"/>
@@ -12775,7 +12775,7 @@
             <a:r>
               <a:rPr lang="en-US" sz="1000" dirty="0">
                 <a:solidFill>
-                  <a:srgbClr val="F8FAFC"/>
+                  <a:srgbClr val="0F172A"/>
                 </a:solidFill>
                 <a:latin typeface="Courier" pitchFamily="34" charset="0"/>
                 <a:ea typeface="Courier" pitchFamily="34" charset="-122"/>
@@ -12795,7 +12795,7 @@
             <a:r>
               <a:rPr lang="en-US" sz="1000" dirty="0">
                 <a:solidFill>
-                  <a:srgbClr val="F8FAFC"/>
+                  <a:srgbClr val="0F172A"/>
                 </a:solidFill>
                 <a:latin typeface="Courier" pitchFamily="34" charset="0"/>
                 <a:ea typeface="Courier" pitchFamily="34" charset="-122"/>
@@ -12815,7 +12815,7 @@
             <a:r>
               <a:rPr lang="en-US" sz="1000" dirty="0">
                 <a:solidFill>
-                  <a:srgbClr val="F8FAFC"/>
+                  <a:srgbClr val="0F172A"/>
                 </a:solidFill>
                 <a:latin typeface="Courier" pitchFamily="34" charset="0"/>
                 <a:ea typeface="Courier" pitchFamily="34" charset="-122"/>
@@ -12844,7 +12844,7 @@
             <a:r>
               <a:rPr lang="en-US" sz="1000" dirty="0">
                 <a:solidFill>
-                  <a:srgbClr val="F8FAFC"/>
+                  <a:srgbClr val="0F172A"/>
                 </a:solidFill>
                 <a:latin typeface="Courier" pitchFamily="34" charset="0"/>
                 <a:ea typeface="Courier" pitchFamily="34" charset="-122"/>
@@ -12873,7 +12873,7 @@
             <a:r>
               <a:rPr lang="en-US" sz="1000" dirty="0">
                 <a:solidFill>
-                  <a:srgbClr val="F8FAFC"/>
+                  <a:srgbClr val="0F172A"/>
                 </a:solidFill>
                 <a:latin typeface="Courier" pitchFamily="34" charset="0"/>
                 <a:ea typeface="Courier" pitchFamily="34" charset="-122"/>
@@ -12899,7 +12899,7 @@
     <p:bg>
       <p:bgPr>
         <a:solidFill>
-          <a:srgbClr val="0B0F19"/>
+          <a:srgbClr val="F8FAFC"/>
         </a:solidFill>
       </p:bgPr>
     </p:bg>
@@ -12934,7 +12934,7 @@
           <a:noFill/>
           <a:ln w="12700">
             <a:solidFill>
-              <a:srgbClr val="2A3B5C"/>
+              <a:srgbClr val="E2E8F0"/>
             </a:solidFill>
             <a:prstDash val="solid"/>
           </a:ln>
@@ -13084,7 +13084,7 @@
             <a:r>
               <a:rPr lang="en-US" sz="1800" b="1" dirty="0">
                 <a:solidFill>
-                  <a:srgbClr val="F8FAFC"/>
+                  <a:srgbClr val="0F172A"/>
                 </a:solidFill>
                 <a:latin typeface="Arial" pitchFamily="34" charset="0"/>
                 <a:ea typeface="Arial" pitchFamily="34" charset="-122"/>
@@ -13113,7 +13113,7 @@
           <a:noFill/>
           <a:ln w="12700">
             <a:solidFill>
-              <a:srgbClr val="2A3B5C"/>
+              <a:srgbClr val="E2E8F0"/>
             </a:solidFill>
             <a:prstDash val="solid"/>
           </a:ln>
@@ -13212,11 +13212,11 @@
             <a:avLst/>
           </a:prstGeom>
           <a:solidFill>
-            <a:srgbClr val="131B2B"/>
+            <a:srgbClr val="FFFFFF"/>
           </a:solidFill>
           <a:ln w="12700">
             <a:solidFill>
-              <a:srgbClr val="2A3B5C"/>
+              <a:srgbClr val="E2E8F0"/>
             </a:solidFill>
             <a:prstDash val="solid"/>
           </a:ln>
@@ -13252,7 +13252,7 @@
             <a:r>
               <a:rPr lang="en-US" sz="1000" dirty="0">
                 <a:solidFill>
-                  <a:srgbClr val="F8FAFC"/>
+                  <a:srgbClr val="0F172A"/>
                 </a:solidFill>
                 <a:latin typeface="Courier" pitchFamily="34" charset="0"/>
                 <a:ea typeface="Courier" pitchFamily="34" charset="-122"/>
@@ -13272,7 +13272,7 @@
             <a:r>
               <a:rPr lang="en-US" sz="1000" dirty="0">
                 <a:solidFill>
-                  <a:srgbClr val="F8FAFC"/>
+                  <a:srgbClr val="0F172A"/>
                 </a:solidFill>
                 <a:latin typeface="Courier" pitchFamily="34" charset="0"/>
                 <a:ea typeface="Courier" pitchFamily="34" charset="-122"/>
@@ -13292,7 +13292,7 @@
             <a:r>
               <a:rPr lang="en-US" sz="1000" dirty="0">
                 <a:solidFill>
-                  <a:srgbClr val="F8FAFC"/>
+                  <a:srgbClr val="0F172A"/>
                 </a:solidFill>
                 <a:latin typeface="Courier" pitchFamily="34" charset="0"/>
                 <a:ea typeface="Courier" pitchFamily="34" charset="-122"/>
@@ -13312,7 +13312,7 @@
             <a:r>
               <a:rPr lang="en-US" sz="1000" dirty="0">
                 <a:solidFill>
-                  <a:srgbClr val="F8FAFC"/>
+                  <a:srgbClr val="0F172A"/>
                 </a:solidFill>
                 <a:latin typeface="Courier" pitchFamily="34" charset="0"/>
                 <a:ea typeface="Courier" pitchFamily="34" charset="-122"/>
@@ -13332,7 +13332,7 @@
             <a:r>
               <a:rPr lang="en-US" sz="1000" dirty="0">
                 <a:solidFill>
-                  <a:srgbClr val="F8FAFC"/>
+                  <a:srgbClr val="0F172A"/>
                 </a:solidFill>
                 <a:latin typeface="Courier" pitchFamily="34" charset="0"/>
                 <a:ea typeface="Courier" pitchFamily="34" charset="-122"/>
@@ -13358,7 +13358,7 @@
     <p:bg>
       <p:bgPr>
         <a:solidFill>
-          <a:srgbClr val="0B0F19"/>
+          <a:srgbClr val="F8FAFC"/>
         </a:solidFill>
       </p:bgPr>
     </p:bg>
@@ -13393,7 +13393,7 @@
           <a:noFill/>
           <a:ln w="12700">
             <a:solidFill>
-              <a:srgbClr val="2A3B5C"/>
+              <a:srgbClr val="E2E8F0"/>
             </a:solidFill>
             <a:prstDash val="solid"/>
           </a:ln>
@@ -13543,7 +13543,7 @@
             <a:r>
               <a:rPr lang="en-US" sz="1800" b="1" dirty="0">
                 <a:solidFill>
-                  <a:srgbClr val="F8FAFC"/>
+                  <a:srgbClr val="0F172A"/>
                 </a:solidFill>
                 <a:latin typeface="Arial" pitchFamily="34" charset="0"/>
                 <a:ea typeface="Arial" pitchFamily="34" charset="-122"/>
@@ -13572,7 +13572,7 @@
           <a:noFill/>
           <a:ln w="12700">
             <a:solidFill>
-              <a:srgbClr val="2A3B5C"/>
+              <a:srgbClr val="E2E8F0"/>
             </a:solidFill>
             <a:prstDash val="solid"/>
           </a:ln>
@@ -13671,11 +13671,11 @@
             <a:avLst/>
           </a:prstGeom>
           <a:solidFill>
-            <a:srgbClr val="131B2B"/>
+            <a:srgbClr val="FFFFFF"/>
           </a:solidFill>
           <a:ln w="12700">
             <a:solidFill>
-              <a:srgbClr val="2A3B5C"/>
+              <a:srgbClr val="E2E8F0"/>
             </a:solidFill>
             <a:prstDash val="solid"/>
           </a:ln>
@@ -13711,7 +13711,7 @@
             <a:r>
               <a:rPr lang="en-US" sz="1000" dirty="0">
                 <a:solidFill>
-                  <a:srgbClr val="F8FAFC"/>
+                  <a:srgbClr val="0F172A"/>
                 </a:solidFill>
                 <a:latin typeface="Courier" pitchFamily="34" charset="0"/>
                 <a:ea typeface="Courier" pitchFamily="34" charset="-122"/>
@@ -13740,7 +13740,7 @@
             <a:r>
               <a:rPr lang="en-US" sz="1000" dirty="0">
                 <a:solidFill>
-                  <a:srgbClr val="F8FAFC"/>
+                  <a:srgbClr val="0F172A"/>
                 </a:solidFill>
                 <a:latin typeface="Courier" pitchFamily="34" charset="0"/>
                 <a:ea typeface="Courier" pitchFamily="34" charset="-122"/>
@@ -13760,7 +13760,7 @@
             <a:r>
               <a:rPr lang="en-US" sz="1000" dirty="0">
                 <a:solidFill>
-                  <a:srgbClr val="F8FAFC"/>
+                  <a:srgbClr val="0F172A"/>
                 </a:solidFill>
                 <a:latin typeface="Courier" pitchFamily="34" charset="0"/>
                 <a:ea typeface="Courier" pitchFamily="34" charset="-122"/>
@@ -13780,7 +13780,7 @@
             <a:r>
               <a:rPr lang="en-US" sz="1000" dirty="0">
                 <a:solidFill>
-                  <a:srgbClr val="F8FAFC"/>
+                  <a:srgbClr val="0F172A"/>
                 </a:solidFill>
                 <a:latin typeface="Courier" pitchFamily="34" charset="0"/>
                 <a:ea typeface="Courier" pitchFamily="34" charset="-122"/>
@@ -13800,7 +13800,7 @@
             <a:r>
               <a:rPr lang="en-US" sz="1000" dirty="0">
                 <a:solidFill>
-                  <a:srgbClr val="F8FAFC"/>
+                  <a:srgbClr val="0F172A"/>
                 </a:solidFill>
                 <a:latin typeface="Courier" pitchFamily="34" charset="0"/>
                 <a:ea typeface="Courier" pitchFamily="34" charset="-122"/>
@@ -13820,7 +13820,7 @@
             <a:r>
               <a:rPr lang="en-US" sz="1000" dirty="0">
                 <a:solidFill>
-                  <a:srgbClr val="F8FAFC"/>
+                  <a:srgbClr val="0F172A"/>
                 </a:solidFill>
                 <a:latin typeface="Courier" pitchFamily="34" charset="0"/>
                 <a:ea typeface="Courier" pitchFamily="34" charset="-122"/>
@@ -13846,7 +13846,7 @@
     <p:bg>
       <p:bgPr>
         <a:solidFill>
-          <a:srgbClr val="0B0F19"/>
+          <a:srgbClr val="F8FAFC"/>
         </a:solidFill>
       </p:bgPr>
     </p:bg>
@@ -13881,7 +13881,7 @@
           <a:noFill/>
           <a:ln w="12700">
             <a:solidFill>
-              <a:srgbClr val="2A3B5C"/>
+              <a:srgbClr val="E2E8F0"/>
             </a:solidFill>
             <a:prstDash val="solid"/>
           </a:ln>
@@ -14031,7 +14031,7 @@
             <a:r>
               <a:rPr lang="en-US" sz="1800" b="1" dirty="0">
                 <a:solidFill>
-                  <a:srgbClr val="F8FAFC"/>
+                  <a:srgbClr val="0F172A"/>
                 </a:solidFill>
                 <a:latin typeface="Arial" pitchFamily="34" charset="0"/>
                 <a:ea typeface="Arial" pitchFamily="34" charset="-122"/>
@@ -14060,7 +14060,7 @@
           <a:noFill/>
           <a:ln w="12700">
             <a:solidFill>
-              <a:srgbClr val="2A3B5C"/>
+              <a:srgbClr val="E2E8F0"/>
             </a:solidFill>
             <a:prstDash val="solid"/>
           </a:ln>
@@ -14159,11 +14159,11 @@
             <a:avLst/>
           </a:prstGeom>
           <a:solidFill>
-            <a:srgbClr val="131B2B"/>
+            <a:srgbClr val="FFFFFF"/>
           </a:solidFill>
           <a:ln w="12700">
             <a:solidFill>
-              <a:srgbClr val="2A3B5C"/>
+              <a:srgbClr val="E2E8F0"/>
             </a:solidFill>
             <a:prstDash val="solid"/>
           </a:ln>
@@ -14199,7 +14199,7 @@
             <a:r>
               <a:rPr lang="en-US" sz="1000" dirty="0">
                 <a:solidFill>
-                  <a:srgbClr val="F8FAFC"/>
+                  <a:srgbClr val="0F172A"/>
                 </a:solidFill>
                 <a:latin typeface="Courier" pitchFamily="34" charset="0"/>
                 <a:ea typeface="Courier" pitchFamily="34" charset="-122"/>
@@ -14219,7 +14219,7 @@
             <a:r>
               <a:rPr lang="en-US" sz="1000" dirty="0">
                 <a:solidFill>
-                  <a:srgbClr val="F8FAFC"/>
+                  <a:srgbClr val="0F172A"/>
                 </a:solidFill>
                 <a:latin typeface="Courier" pitchFamily="34" charset="0"/>
                 <a:ea typeface="Courier" pitchFamily="34" charset="-122"/>
@@ -14239,7 +14239,7 @@
             <a:r>
               <a:rPr lang="en-US" sz="1000" dirty="0">
                 <a:solidFill>
-                  <a:srgbClr val="F8FAFC"/>
+                  <a:srgbClr val="0F172A"/>
                 </a:solidFill>
                 <a:latin typeface="Courier" pitchFamily="34" charset="0"/>
                 <a:ea typeface="Courier" pitchFamily="34" charset="-122"/>
@@ -14268,7 +14268,7 @@
             <a:r>
               <a:rPr lang="en-US" sz="1000" dirty="0">
                 <a:solidFill>
-                  <a:srgbClr val="F8FAFC"/>
+                  <a:srgbClr val="0F172A"/>
                 </a:solidFill>
                 <a:latin typeface="Courier" pitchFamily="34" charset="0"/>
                 <a:ea typeface="Courier" pitchFamily="34" charset="-122"/>
@@ -14288,7 +14288,7 @@
             <a:r>
               <a:rPr lang="en-US" sz="1000" dirty="0">
                 <a:solidFill>
-                  <a:srgbClr val="F8FAFC"/>
+                  <a:srgbClr val="0F172A"/>
                 </a:solidFill>
                 <a:latin typeface="Courier" pitchFamily="34" charset="0"/>
                 <a:ea typeface="Courier" pitchFamily="34" charset="-122"/>
@@ -14308,7 +14308,7 @@
             <a:r>
               <a:rPr lang="en-US" sz="1000" dirty="0">
                 <a:solidFill>
-                  <a:srgbClr val="F8FAFC"/>
+                  <a:srgbClr val="0F172A"/>
                 </a:solidFill>
                 <a:latin typeface="Courier" pitchFamily="34" charset="0"/>
                 <a:ea typeface="Courier" pitchFamily="34" charset="-122"/>
@@ -14337,7 +14337,7 @@
             <a:r>
               <a:rPr lang="en-US" sz="1000" dirty="0">
                 <a:solidFill>
-                  <a:srgbClr val="F8FAFC"/>
+                  <a:srgbClr val="0F172A"/>
                 </a:solidFill>
                 <a:latin typeface="Courier" pitchFamily="34" charset="0"/>
                 <a:ea typeface="Courier" pitchFamily="34" charset="-122"/>
@@ -14357,7 +14357,7 @@
             <a:r>
               <a:rPr lang="en-US" sz="1000" dirty="0">
                 <a:solidFill>
-                  <a:srgbClr val="F8FAFC"/>
+                  <a:srgbClr val="0F172A"/>
                 </a:solidFill>
                 <a:latin typeface="Courier" pitchFamily="34" charset="0"/>
                 <a:ea typeface="Courier" pitchFamily="34" charset="-122"/>
@@ -14377,7 +14377,7 @@
             <a:r>
               <a:rPr lang="en-US" sz="1000" dirty="0">
                 <a:solidFill>
-                  <a:srgbClr val="F8FAFC"/>
+                  <a:srgbClr val="0F172A"/>
                 </a:solidFill>
                 <a:latin typeface="Courier" pitchFamily="34" charset="0"/>
                 <a:ea typeface="Courier" pitchFamily="34" charset="-122"/>
@@ -14403,7 +14403,7 @@
     <p:bg>
       <p:bgPr>
         <a:solidFill>
-          <a:srgbClr val="0B0F19"/>
+          <a:srgbClr val="F8FAFC"/>
         </a:solidFill>
       </p:bgPr>
     </p:bg>
@@ -14438,7 +14438,7 @@
           <a:noFill/>
           <a:ln w="12700">
             <a:solidFill>
-              <a:srgbClr val="2A3B5C"/>
+              <a:srgbClr val="E2E8F0"/>
             </a:solidFill>
             <a:prstDash val="solid"/>
           </a:ln>
@@ -14588,7 +14588,7 @@
             <a:r>
               <a:rPr lang="en-US" sz="1800" b="1" dirty="0">
                 <a:solidFill>
-                  <a:srgbClr val="F8FAFC"/>
+                  <a:srgbClr val="0F172A"/>
                 </a:solidFill>
                 <a:latin typeface="Arial" pitchFamily="34" charset="0"/>
                 <a:ea typeface="Arial" pitchFamily="34" charset="-122"/>
@@ -14617,7 +14617,7 @@
           <a:noFill/>
           <a:ln w="12700">
             <a:solidFill>
-              <a:srgbClr val="2A3B5C"/>
+              <a:srgbClr val="E2E8F0"/>
             </a:solidFill>
             <a:prstDash val="solid"/>
           </a:ln>
@@ -14716,11 +14716,11 @@
             <a:avLst/>
           </a:prstGeom>
           <a:solidFill>
-            <a:srgbClr val="131B2B"/>
+            <a:srgbClr val="FFFFFF"/>
           </a:solidFill>
           <a:ln w="12700">
             <a:solidFill>
-              <a:srgbClr val="2A3B5C"/>
+              <a:srgbClr val="E2E8F0"/>
             </a:solidFill>
             <a:prstDash val="solid"/>
           </a:ln>
@@ -14756,7 +14756,7 @@
             <a:r>
               <a:rPr lang="en-US" sz="1000" dirty="0">
                 <a:solidFill>
-                  <a:srgbClr val="F8FAFC"/>
+                  <a:srgbClr val="0F172A"/>
                 </a:solidFill>
                 <a:latin typeface="Courier" pitchFamily="34" charset="0"/>
                 <a:ea typeface="Courier" pitchFamily="34" charset="-122"/>
@@ -14776,7 +14776,7 @@
             <a:r>
               <a:rPr lang="en-US" sz="1000" dirty="0">
                 <a:solidFill>
-                  <a:srgbClr val="F8FAFC"/>
+                  <a:srgbClr val="0F172A"/>
                 </a:solidFill>
                 <a:latin typeface="Courier" pitchFamily="34" charset="0"/>
                 <a:ea typeface="Courier" pitchFamily="34" charset="-122"/>
@@ -14796,7 +14796,7 @@
             <a:r>
               <a:rPr lang="en-US" sz="1000" dirty="0">
                 <a:solidFill>
-                  <a:srgbClr val="F8FAFC"/>
+                  <a:srgbClr val="0F172A"/>
                 </a:solidFill>
                 <a:latin typeface="Courier" pitchFamily="34" charset="0"/>
                 <a:ea typeface="Courier" pitchFamily="34" charset="-122"/>
@@ -14816,7 +14816,7 @@
             <a:r>
               <a:rPr lang="en-US" sz="1000" dirty="0">
                 <a:solidFill>
-                  <a:srgbClr val="F8FAFC"/>
+                  <a:srgbClr val="0F172A"/>
                 </a:solidFill>
                 <a:latin typeface="Courier" pitchFamily="34" charset="0"/>
                 <a:ea typeface="Courier" pitchFamily="34" charset="-122"/>
@@ -14836,7 +14836,7 @@
             <a:r>
               <a:rPr lang="en-US" sz="1000" dirty="0">
                 <a:solidFill>
-                  <a:srgbClr val="F8FAFC"/>
+                  <a:srgbClr val="0F172A"/>
                 </a:solidFill>
                 <a:latin typeface="Courier" pitchFamily="34" charset="0"/>
                 <a:ea typeface="Courier" pitchFamily="34" charset="-122"/>
@@ -14856,7 +14856,7 @@
             <a:r>
               <a:rPr lang="en-US" sz="1000" dirty="0">
                 <a:solidFill>
-                  <a:srgbClr val="F8FAFC"/>
+                  <a:srgbClr val="0F172A"/>
                 </a:solidFill>
                 <a:latin typeface="Courier" pitchFamily="34" charset="0"/>
                 <a:ea typeface="Courier" pitchFamily="34" charset="-122"/>
@@ -14876,7 +14876,7 @@
             <a:r>
               <a:rPr lang="en-US" sz="1000" dirty="0">
                 <a:solidFill>
-                  <a:srgbClr val="F8FAFC"/>
+                  <a:srgbClr val="0F172A"/>
                 </a:solidFill>
                 <a:latin typeface="Courier" pitchFamily="34" charset="0"/>
                 <a:ea typeface="Courier" pitchFamily="34" charset="-122"/>

</xml_diff>